<commit_message>
docs(arch-deck): SCN-only content - drop cross-project mentions
Generated with [Devin](https://devin.ai)

Co-Authored-By: Devin <158243242+devin-ai-integration[bot]@users.noreply.github.com>
</commit_message>
<xml_diff>
--- a/docs/handover/KIEN-TRUC-HE-THONG.pptx
+++ b/docs/handover/KIEN-TRUC-HE-THONG.pptx
@@ -3677,7 +3677,7 @@
                           <a:ea typeface="Segoe UI" pitchFamily="34" charset="-122"/>
                           <a:cs typeface="Segoe UI" pitchFamily="34" charset="-120"/>
                         </a:rPr>
-                        <a:t>Chung 1 Supabase project (cxjpgfhqchjoernfmcra) - SCN bảng thường, tvc360 bảng tvc_*</a:t>
+                        <a:t>Chung 1 Supabase project với một app nội bộ khác - tách bằng table naming + RLS</a:t>
                       </a:r>
                       <a:endParaRPr lang="en-US" sz="1050" dirty="0">
                         <a:latin typeface="Segoe UI" charset="0"/>
@@ -3745,7 +3745,7 @@
                           <a:ea typeface="Segoe UI" pitchFamily="34" charset="-122"/>
                           <a:cs typeface="Segoe UI" pitchFamily="34" charset="-120"/>
                         </a:rPr>
-                        <a:t>DB riêng mỗi sản phẩm</a:t>
+                        <a:t>DB riêng cho SCN</a:t>
                       </a:r>
                       <a:endParaRPr lang="en-US" sz="1050" dirty="0">
                         <a:latin typeface="Segoe UI" charset="0"/>
@@ -10731,7 +10731,7 @@
                           <a:ea typeface="Segoe UI" pitchFamily="34" charset="-122"/>
                           <a:cs typeface="Segoe UI" pitchFamily="34" charset="-120"/>
                         </a:rPr>
-                        <a:t>Chung Supabase project với tvc360 - nhiễu resource</a:t>
+                        <a:t>Chung Supabase project với app nội bộ khác - nhiễu resource</a:t>
                       </a:r>
                       <a:endParaRPr lang="en-US" sz="1050" dirty="0">
                         <a:latin typeface="Segoe UI" charset="0"/>
@@ -12567,7 +12567,7 @@
                           <a:ea typeface="Segoe UI" pitchFamily="34" charset="-122"/>
                           <a:cs typeface="Segoe UI" pitchFamily="34" charset="-120"/>
                         </a:rPr>
-                        <a:t>Supabase pooler + partition attendance_records theo academic_year; tách Supabase project theo sản phẩm</a:t>
+                        <a:t>Supabase pooler + partition attendance_records theo academic_year; tách Supabase project riêng cho SCN</a:t>
                       </a:r>
                       <a:endParaRPr lang="en-US" sz="1050" dirty="0">
                         <a:latin typeface="Segoe UI" charset="0"/>
@@ -15309,7 +15309,7 @@
                 <a:ea typeface="Segoe UI" pitchFamily="34" charset="-122"/>
                 <a:cs typeface="Segoe UI" pitchFamily="34" charset="-120"/>
               </a:rPr>
-              <a:t>Polyrepo + shared SDLC harness thay monorepo: sản phẩm độc lập lifecycle, conventions vẫn thống nhất</a:t>
+              <a:t>Repo riêng single-package thay monorepo: SCN là bounded context hoàn chỉnh, deploy boundary = domain boundary</a:t>
             </a:r>
             <a:endParaRPr lang="en-US" sz="1350" dirty="0"/>
           </a:p>
@@ -16352,7 +16352,7 @@
                 <a:ea typeface="Segoe UI" pitchFamily="34" charset="-122"/>
                 <a:cs typeface="Segoe UI" pitchFamily="34" charset="-120"/>
               </a:rPr>
-              <a:t>Async có nhưng không có broker: Vercel cron + ai_jobs table + webhook callback (Resend) + Devin async fallback</a:t>
+              <a:t>Async có nhưng không có broker: Vercel cron + ai_jobs table + webhook callback (Resend) + async fallback</a:t>
             </a:r>
             <a:endParaRPr lang="en-US" sz="1250" dirty="0"/>
           </a:p>
@@ -16373,7 +16373,7 @@
                 <a:ea typeface="Segoe UI" pitchFamily="34" charset="-122"/>
                 <a:cs typeface="Segoe UI" pitchFamily="34" charset="-120"/>
               </a:rPr>
-              <a:t>Supabase project chung với sản phẩm khác (tvc360) - tách biệt bằng RLS, không phải DB riêng</a:t>
+              <a:t>Supabase project chung với một sản phẩm nội bộ khác - tách biệt bằng RLS, không phải DB riêng</a:t>
             </a:r>
             <a:endParaRPr lang="en-US" sz="1250" dirty="0"/>
           </a:p>
@@ -22928,7 +22928,7 @@
                 <a:ea typeface="Segoe UI" pitchFamily="34" charset="-122"/>
                 <a:cs typeface="Segoe UI" pitchFamily="34" charset="-120"/>
               </a:rPr>
-              <a:t>Repo topology: polyrepo + shared harness, không phải monorepo</a:t>
+              <a:t>Repo topology: một repo một sản phẩm, không phải monorepo</a:t>
             </a:r>
             <a:endParaRPr lang="en-US" sz="2600" dirty="0"/>
           </a:p>
@@ -23148,7 +23148,7 @@
                           <a:ea typeface="Segoe UI" pitchFamily="34" charset="-122"/>
                           <a:cs typeface="Segoe UI" pitchFamily="34" charset="-120"/>
                         </a:rPr>
-                        <a:t>Polyrepo hiện tại (đã chọn)</a:t>
+                        <a:t>Repo riêng hiện tại (đã chọn)</a:t>
                       </a:r>
                       <a:endParaRPr lang="en-US" sz="1100" dirty="0">
                         <a:latin typeface="Segoe UI" charset="0"/>
@@ -23354,7 +23354,7 @@
                           <a:ea typeface="Segoe UI" pitchFamily="34" charset="-122"/>
                           <a:cs typeface="Segoe UI" pitchFamily="34" charset="-120"/>
                         </a:rPr>
-                        <a:t>Mỗi sản phẩm 1 repo: scn, tvc360, slideforge, ssp, aal-site... deploy độc lập</a:t>
+                        <a:t>SCN là 1 repo độc lập, single-package (không workspaces), push master - deploy đúng project</a:t>
                       </a:r>
                       <a:endParaRPr lang="en-US" sz="1050" dirty="0">
                         <a:latin typeface="Segoe UI" charset="0"/>
@@ -23422,7 +23422,7 @@
                           <a:ea typeface="Segoe UI" pitchFamily="34" charset="-122"/>
                           <a:cs typeface="Segoe UI" pitchFamily="34" charset="-120"/>
                         </a:rPr>
-                        <a:t>Một repo chứa tất cả apps + packages chung</a:t>
+                        <a:t>Một repo chứa nhiều apps + packages chung</a:t>
                       </a:r>
                       <a:endParaRPr lang="en-US" sz="1050" dirty="0">
                         <a:latin typeface="Segoe UI" charset="0"/>
@@ -23766,7 +23766,7 @@
                           <a:ea typeface="Segoe UI" pitchFamily="34" charset="-122"/>
                           <a:cs typeface="Segoe UI" pitchFamily="34" charset="-120"/>
                         </a:rPr>
-                        <a:t>Chia sẻ qua SDLC harness (scripts/skills vendored vào từng repo) - không phải packages</a:t>
+                        <a:t>Chia sẻ qua harness scripts/skills vendored vào repo - không phải packages</a:t>
                       </a:r>
                       <a:endParaRPr lang="en-US" sz="1050" dirty="0">
                         <a:latin typeface="Segoe UI" charset="0"/>
@@ -24384,7 +24384,7 @@
                           <a:ea typeface="Segoe UI" pitchFamily="34" charset="-122"/>
                           <a:cs typeface="Segoe UI" pitchFamily="34" charset="-120"/>
                         </a:rPr>
-                        <a:t>Các sản phẩm ĐỘC LẬP khách hàng/lifecycle - không share domain model</a:t>
+                        <a:t>SCN độc lập lifecycle/khách hàng - không share domain model với ai</a:t>
                       </a:r>
                       <a:endParaRPr lang="en-US" sz="1050" dirty="0">
                         <a:latin typeface="Segoe UI" charset="0"/>
@@ -24452,7 +24452,7 @@
                           <a:ea typeface="Segoe UI" pitchFamily="34" charset="-122"/>
                           <a:cs typeface="Segoe UI" pitchFamily="34" charset="-120"/>
                         </a:rPr>
-                        <a:t>Chỉ đúng nếu các app chia sẻ domain model chung - SCN không có nhu cầu đó</a:t>
+                        <a:t>Chỉ đúng nếu nhiều app chia sẻ domain model chung - SCN không có nhu cầu đó</a:t>
                       </a:r>
                       <a:endParaRPr lang="en-US" sz="1050" dirty="0">
                         <a:latin typeface="Segoe UI" charset="0"/>
@@ -24541,7 +24541,7 @@
                 <a:ea typeface="Segoe UI" pitchFamily="34" charset="-122"/>
                 <a:cs typeface="Segoe UI" pitchFamily="34" charset="-120"/>
               </a:rPr>
-              <a:t>Thay cho monorepo: SDLC là 'meta-repo' phân phối conventions/gates/skills xuống từng product repo qua bootstrap-harness.sh.</a:t>
+              <a:t>SCN là bounded context hoàn chỉnh - repo riêng phản ánh đúng ranh giới deploy và ranh giới domain.</a:t>
             </a:r>
             <a:endParaRPr lang="en-US" sz="1050" dirty="0"/>
           </a:p>

</xml_diff>

<commit_message>
docs: sync decks voi wave CR-060..067 - user-guide 43 slides, arch 23 slides
- user-guide: 3 lop module (SCN + Studio + module mo rong ban theo goi),
  5 slide moi: tuyen sinh + cong public /apply, khoan thu, LMS-lite,
  thu vien + bien dong HS, school_features flags; cap nhat ke toan/PH/HS,
  checklist test them 5 kich ban module moi
- arch: 15 bounded contexts, 86 bang public + 3 schema app khac cung project,
  lop 2.5 schoolFeature gating, /apply Turnstile + revoke anon, atomic
  bien lai/DKCB, movements security-definer RPC; limitations them LMS
  cham tay + public apply surface; ket luan cap nhat module flags
- fix slide count message (bao thuc te thay hardcode)
</commit_message>
<xml_diff>
--- a/docs/handover/KIEN-TRUC-HE-THONG.pptx
+++ b/docs/handover/KIEN-TRUC-HE-THONG.pptx
@@ -6142,7 +6142,7 @@
                           <a:ea typeface="Segoe UI" pitchFamily="34" charset="-122"/>
                           <a:cs typeface="Segoe UI" pitchFamily="34" charset="-120"/>
                         </a:rPr>
-                        <a:t>~30 bảng quan hệ chặt + views + RPC</a:t>
+                        <a:t>86 bảng public quan hệ chặt + views + RPC (SCN dùng schema public; app khác ở schema riêng)</a:t>
                       </a:r>
                       <a:endParaRPr lang="en-US" sz="1050" dirty="0">
                         <a:latin typeface="Segoe UI" charset="0"/>
@@ -6278,7 +6278,7 @@
                           <a:ea typeface="Segoe UI" pitchFamily="34" charset="-122"/>
                           <a:cs typeface="Segoe UI" pitchFamily="34" charset="-120"/>
                         </a:rPr>
-                        <a:t>Join chéo là yêu cầu cốt lõi (attendance_daily gộp 2 nguồn) - 1 DB là điều kiện cần</a:t>
+                        <a:t>Join chéo là yêu cầu cốt lõi (attendance_daily gộp 2 nguồn, học bạ kéo điểm + HK + chuyên cần) - 1 DB là điều kiện cần</a:t>
                       </a:r>
                       <a:endParaRPr lang="en-US" sz="1050" dirty="0">
                         <a:latin typeface="Segoe UI" charset="0"/>
@@ -6367,7 +6367,7 @@
                 <a:ea typeface="Segoe UI" pitchFamily="34" charset="-122"/>
                 <a:cs typeface="Segoe UI" pitchFamily="34" charset="-120"/>
               </a:rPr>
-              <a:t>Ưu tiên đơn giản vận hành: 1 project, 1 schema, RLS làm việc nặng phân tách ở mọi cấp.</a:t>
+              <a:t>Ưu tiên đơn giản vận hành: 1 project, RLS làm việc nặng phân tách ở mọi cấp. Schema-per-app đã có sẵn như seam tách project sau này.</a:t>
             </a:r>
             <a:endParaRPr lang="en-US" sz="1050" dirty="0"/>
           </a:p>
@@ -6764,6 +6764,90 @@
                 <a:cs typeface="Segoe UI" pitchFamily="34" charset="-120"/>
               </a:rPr>
               <a:t>check constraints cho enum mở rộng được, triggers sinh notifications - quy tắc nghiệp vụ sống ở tầng không thể bypass</a:t>
+            </a:r>
+            <a:endParaRPr lang="en-US" sz="1250" dirty="0"/>
+          </a:p>
+          <a:p>
+            <a:pPr marL="177800" indent="-177800">
+              <a:spcAft>
+                <a:spcPts val="800"/>
+              </a:spcAft>
+              <a:buSzPct val="100000"/>
+              <a:buChar char="•"/>
+            </a:pPr>
+            <a:r>
+              <a:rPr lang="en-US" sz="1250" dirty="0">
+                <a:solidFill>
+                  <a:srgbClr val="0F172A"/>
+                </a:solidFill>
+                <a:latin typeface="Segoe UI" pitchFamily="34" charset="0"/>
+                <a:ea typeface="Segoe UI" pitchFamily="34" charset="-122"/>
+                <a:cs typeface="Segoe UI" pitchFamily="34" charset="-120"/>
+              </a:rPr>
+              <a:t>Atomic ở nghiệp vụ nhạy cảm</a:t>
+            </a:r>
+            <a:endParaRPr lang="en-US" sz="1250" dirty="0"/>
+          </a:p>
+          <a:p>
+            <a:pPr marL="381000" indent="-381000">
+              <a:spcAft>
+                <a:spcPts val="800"/>
+              </a:spcAft>
+              <a:buSzPct val="100000"/>
+              <a:buChar char="–"/>
+            </a:pPr>
+            <a:r>
+              <a:rPr lang="en-US" sz="1100" dirty="0">
+                <a:solidFill>
+                  <a:srgbClr val="475569"/>
+                </a:solidFill>
+                <a:latin typeface="Segoe UI" pitchFamily="34" charset="0"/>
+                <a:ea typeface="Segoe UI" pitchFamily="34" charset="-122"/>
+                <a:cs typeface="Segoe UI" pitchFamily="34" charset="-120"/>
+              </a:rPr>
+              <a:t>Số biên lai + số ĐKCB đánh atomic theo trường trong RPC (không race khi 2 kế toán thu cùng lúc); mượn/trả sách check tồn trong 1 transaction</a:t>
+            </a:r>
+            <a:endParaRPr lang="en-US" sz="1250" dirty="0"/>
+          </a:p>
+          <a:p>
+            <a:pPr marL="177800" indent="-177800">
+              <a:spcAft>
+                <a:spcPts val="800"/>
+              </a:spcAft>
+              <a:buSzPct val="100000"/>
+              <a:buChar char="•"/>
+            </a:pPr>
+            <a:r>
+              <a:rPr lang="en-US" sz="1250" dirty="0">
+                <a:solidFill>
+                  <a:srgbClr val="0F172A"/>
+                </a:solidFill>
+                <a:latin typeface="Segoe UI" pitchFamily="34" charset="0"/>
+                <a:ea typeface="Segoe UI" pitchFamily="34" charset="-122"/>
+                <a:cs typeface="Segoe UI" pitchFamily="34" charset="-120"/>
+              </a:rPr>
+              <a:t>Movement qua security-definer RPC</a:t>
+            </a:r>
+            <a:endParaRPr lang="en-US" sz="1250" dirty="0"/>
+          </a:p>
+          <a:p>
+            <a:pPr marL="381000" indent="-381000">
+              <a:spcAft>
+                <a:spcPts val="800"/>
+              </a:spcAft>
+              <a:buSzPct val="100000"/>
+              <a:buChar char="–"/>
+            </a:pPr>
+            <a:r>
+              <a:rPr lang="en-US" sz="1100" dirty="0">
+                <a:solidFill>
+                  <a:srgbClr val="475569"/>
+                </a:solidFill>
+                <a:latin typeface="Segoe UI" pitchFamily="34" charset="0"/>
+                <a:ea typeface="Segoe UI" pitchFamily="34" charset="-122"/>
+                <a:cs typeface="Segoe UI" pitchFamily="34" charset="-120"/>
+              </a:rPr>
+              <a:t>Biến động HS: direct table write bị revoke - duyệt chuyển/bảo lưu chỉ qua RPC, snapshot tên+lớp tại thời điểm yêu cầu (audit-sound)</a:t>
             </a:r>
             <a:endParaRPr lang="en-US" sz="1250" dirty="0"/>
           </a:p>
@@ -10109,7 +10193,7 @@
                           <a:ea typeface="Segoe UI" pitchFamily="34" charset="-122"/>
                           <a:cs typeface="Segoe UI" pitchFamily="34" charset="-120"/>
                         </a:rPr>
-                        <a:t>Nhất quán 10 vai trò x 30 bảng</a:t>
+                        <a:t>Nhất quán 10 vai trò x 86 bảng</a:t>
                       </a:r>
                       <a:endParaRPr lang="en-US" sz="1050" dirty="0">
                         <a:latin typeface="Segoe UI" charset="0"/>
@@ -14012,7 +14096,49 @@
                 <a:ea typeface="Segoe UI" pitchFamily="34" charset="-122"/>
                 <a:cs typeface="Segoe UI" pitchFamily="34" charset="-120"/>
               </a:rPr>
-              <a:t>~30 bảng: điểm danh chéo giữa sổ đầu bài và điểm danh ngày, điểm số liên kết hạnh kiểm, KPI chủ nhiệm tổng hợp nhiều nguồn</a:t>
+              <a:t>86 bảng trong schema public: điểm danh chéo sổ đầu bài, điểm số liên kết hạnh kiểm, học bạ, tuyển sinh -&gt; nhập học -&gt; học phí - cùng một học sinh xuyên suốt</a:t>
+            </a:r>
+            <a:endParaRPr lang="en-US" sz="1350" dirty="0"/>
+          </a:p>
+          <a:p>
+            <a:pPr marL="177800" indent="-177800">
+              <a:spcAft>
+                <a:spcPts val="800"/>
+              </a:spcAft>
+              <a:buSzPct val="100000"/>
+              <a:buChar char="•"/>
+            </a:pPr>
+            <a:r>
+              <a:rPr lang="en-US" sz="1350" dirty="0">
+                <a:solidFill>
+                  <a:srgbClr val="0F172A"/>
+                </a:solidFill>
+                <a:latin typeface="Segoe UI" pitchFamily="34" charset="0"/>
+                <a:ea typeface="Segoe UI" pitchFamily="34" charset="-122"/>
+                <a:cs typeface="Segoe UI" pitchFamily="34" charset="-120"/>
+              </a:rPr>
+              <a:t>Bán theo gói tính năng</a:t>
+            </a:r>
+            <a:endParaRPr lang="en-US" sz="1350" dirty="0"/>
+          </a:p>
+          <a:p>
+            <a:pPr marL="381000" indent="-381000">
+              <a:spcAft>
+                <a:spcPts val="800"/>
+              </a:spcAft>
+              <a:buSzPct val="100000"/>
+              <a:buChar char="–"/>
+            </a:pPr>
+            <a:r>
+              <a:rPr lang="en-US" sz="1200" dirty="0">
+                <a:solidFill>
+                  <a:srgbClr val="475569"/>
+                </a:solidFill>
+                <a:latin typeface="Segoe UI" pitchFamily="34" charset="0"/>
+                <a:ea typeface="Segoe UI" pitchFamily="34" charset="-122"/>
+                <a:cs typeface="Segoe UI" pitchFamily="34" charset="-120"/>
+              </a:rPr>
+              <a:t>Trường mua module nào dùng module đó - yêu cầu kiến trúc: gating ở nav + route + RPC + RLS, không chỉ ẩn menu</a:t>
             </a:r>
             <a:endParaRPr lang="en-US" sz="1350" dirty="0"/>
           </a:p>
@@ -16358,7 +16484,7 @@
                           <a:ea typeface="Segoe UI" pitchFamily="34" charset="-122"/>
                           <a:cs typeface="Segoe UI" pitchFamily="34" charset="-120"/>
                         </a:rPr>
-                        <a:t>Chung Supabase project với app nội bộ - noisy neighbor đụng IO budget</a:t>
+                        <a:t>Chung Supabase project: 3 schema app khác cùng project - noisy neighbor đụng IO budget</a:t>
                       </a:r>
                       <a:endParaRPr lang="en-US" sz="1050" dirty="0">
                         <a:latin typeface="Segoe UI" charset="0"/>
@@ -16426,7 +16552,7 @@
                           <a:ea typeface="Segoe UI" pitchFamily="34" charset="-122"/>
                           <a:cs typeface="Segoe UI" pitchFamily="34" charset="-120"/>
                         </a:rPr>
-                        <a:t>CR-058: tách schema app kia sang project riêng; phase 0 inventory xong, không downtime</a:t>
+                        <a:t>CR-058: cô lập theo schema đã có; tách hẳn sang project riêng vẫn pending cutover</a:t>
                       </a:r>
                       <a:endParaRPr lang="en-US" sz="1050" dirty="0">
                         <a:latin typeface="Segoe UI" charset="0"/>
@@ -16494,7 +16620,7 @@
                           <a:ea typeface="Segoe UI" pitchFamily="34" charset="-122"/>
                           <a:cs typeface="Segoe UI" pitchFamily="34" charset="-120"/>
                         </a:rPr>
-                        <a:t>Trung bình - cần Pro project mới + cutover; không phải viết lại code</a:t>
+                        <a:t>Trung bình - cần Pro project mới + cutover có downtime nhỏ; không phải viết lại code</a:t>
                       </a:r>
                       <a:endParaRPr lang="en-US" sz="1050" dirty="0">
                         <a:latin typeface="Segoe UI" charset="0"/>
@@ -16542,6 +16668,212 @@
                     </a:lnB>
                     <a:solidFill>
                       <a:srgbClr val="F8FAFC"/>
+                    </a:solidFill>
+                  </a:tcPr>
+                </a:tc>
+              </a:tr>
+              <a:tr h="658368">
+                <a:tc>
+                  <a:txBody>
+                    <a:bodyPr/>
+                    <a:lstStyle/>
+                    <a:p>
+                      <a:pPr indent="0" marL="0">
+                        <a:buNone/>
+                      </a:pPr>
+                      <a:r>
+                        <a:rPr lang="en-US" sz="1050" dirty="0">
+                          <a:solidFill>
+                            <a:srgbClr val="0F172A"/>
+                          </a:solidFill>
+                          <a:latin typeface="Segoe UI" pitchFamily="34" charset="0"/>
+                          <a:ea typeface="Segoe UI" pitchFamily="34" charset="-122"/>
+                          <a:cs typeface="Segoe UI" pitchFamily="34" charset="-120"/>
+                        </a:rPr>
+                        <a:t>Cổng public /apply - surface đầu tiên không cần login</a:t>
+                      </a:r>
+                      <a:endParaRPr lang="en-US" sz="1050" dirty="0">
+                        <a:latin typeface="Segoe UI" charset="0"/>
+                        <a:ea typeface="Segoe UI" charset="0"/>
+                        <a:cs typeface="Segoe UI" charset="0"/>
+                      </a:endParaRPr>
+                    </a:p>
+                  </a:txBody>
+                  <a:tcPr marL="73152" marR="73152" marT="73152" marB="73152" anchor="ctr">
+                    <a:lnL w="9525" cap="flat" cmpd="sng" algn="ctr">
+                      <a:solidFill>
+                        <a:srgbClr val="E2E8F0"/>
+                      </a:solidFill>
+                      <a:prstDash val="solid"/>
+                      <a:round/>
+                      <a:headEnd type="none" w="med" len="med"/>
+                      <a:tailEnd type="none" w="med" len="med"/>
+                    </a:lnL>
+                    <a:lnR w="9525" cap="flat" cmpd="sng" algn="ctr">
+                      <a:solidFill>
+                        <a:srgbClr val="E2E8F0"/>
+                      </a:solidFill>
+                      <a:prstDash val="solid"/>
+                      <a:round/>
+                      <a:headEnd type="none" w="med" len="med"/>
+                      <a:tailEnd type="none" w="med" len="med"/>
+                    </a:lnR>
+                    <a:lnT w="9525" cap="flat" cmpd="sng" algn="ctr">
+                      <a:solidFill>
+                        <a:srgbClr val="E2E8F0"/>
+                      </a:solidFill>
+                      <a:prstDash val="solid"/>
+                      <a:round/>
+                      <a:headEnd type="none" w="med" len="med"/>
+                      <a:tailEnd type="none" w="med" len="med"/>
+                    </a:lnT>
+                    <a:lnB w="9525" cap="flat" cmpd="sng" algn="ctr">
+                      <a:solidFill>
+                        <a:srgbClr val="E2E8F0"/>
+                      </a:solidFill>
+                      <a:prstDash val="solid"/>
+                      <a:round/>
+                      <a:headEnd type="none" w="med" len="med"/>
+                      <a:tailEnd type="none" w="med" len="med"/>
+                    </a:lnB>
+                    <a:solidFill>
+                      <a:srgbClr val="FFFFFF"/>
+                    </a:solidFill>
+                  </a:tcPr>
+                </a:tc>
+                <a:tc>
+                  <a:txBody>
+                    <a:bodyPr/>
+                    <a:lstStyle/>
+                    <a:p>
+                      <a:pPr indent="0" marL="0">
+                        <a:buNone/>
+                      </a:pPr>
+                      <a:r>
+                        <a:rPr lang="en-US" sz="1050" dirty="0">
+                          <a:solidFill>
+                            <a:srgbClr val="0F172A"/>
+                          </a:solidFill>
+                          <a:latin typeface="Segoe UI" pitchFamily="34" charset="0"/>
+                          <a:ea typeface="Segoe UI" pitchFamily="34" charset="-122"/>
+                          <a:cs typeface="Segoe UI" pitchFamily="34" charset="-120"/>
+                        </a:rPr>
+                        <a:t>CR-063 hardening: Turnstile + revoke anon + chỉ RPC security-definer ghi được</a:t>
+                      </a:r>
+                      <a:endParaRPr lang="en-US" sz="1050" dirty="0">
+                        <a:latin typeface="Segoe UI" charset="0"/>
+                        <a:ea typeface="Segoe UI" charset="0"/>
+                        <a:cs typeface="Segoe UI" charset="0"/>
+                      </a:endParaRPr>
+                    </a:p>
+                  </a:txBody>
+                  <a:tcPr marL="73152" marR="73152" marT="73152" marB="73152" anchor="ctr">
+                    <a:lnL w="9525" cap="flat" cmpd="sng" algn="ctr">
+                      <a:solidFill>
+                        <a:srgbClr val="E2E8F0"/>
+                      </a:solidFill>
+                      <a:prstDash val="solid"/>
+                      <a:round/>
+                      <a:headEnd type="none" w="med" len="med"/>
+                      <a:tailEnd type="none" w="med" len="med"/>
+                    </a:lnL>
+                    <a:lnR w="9525" cap="flat" cmpd="sng" algn="ctr">
+                      <a:solidFill>
+                        <a:srgbClr val="E2E8F0"/>
+                      </a:solidFill>
+                      <a:prstDash val="solid"/>
+                      <a:round/>
+                      <a:headEnd type="none" w="med" len="med"/>
+                      <a:tailEnd type="none" w="med" len="med"/>
+                    </a:lnR>
+                    <a:lnT w="9525" cap="flat" cmpd="sng" algn="ctr">
+                      <a:solidFill>
+                        <a:srgbClr val="E2E8F0"/>
+                      </a:solidFill>
+                      <a:prstDash val="solid"/>
+                      <a:round/>
+                      <a:headEnd type="none" w="med" len="med"/>
+                      <a:tailEnd type="none" w="med" len="med"/>
+                    </a:lnT>
+                    <a:lnB w="9525" cap="flat" cmpd="sng" algn="ctr">
+                      <a:solidFill>
+                        <a:srgbClr val="E2E8F0"/>
+                      </a:solidFill>
+                      <a:prstDash val="solid"/>
+                      <a:round/>
+                      <a:headEnd type="none" w="med" len="med"/>
+                      <a:tailEnd type="none" w="med" len="med"/>
+                    </a:lnB>
+                    <a:solidFill>
+                      <a:srgbClr val="FFFFFF"/>
+                    </a:solidFill>
+                  </a:tcPr>
+                </a:tc>
+                <a:tc>
+                  <a:txBody>
+                    <a:bodyPr/>
+                    <a:lstStyle/>
+                    <a:p>
+                      <a:pPr indent="0" marL="0">
+                        <a:buNone/>
+                      </a:pPr>
+                      <a:r>
+                        <a:rPr lang="en-US" sz="1050" dirty="0">
+                          <a:solidFill>
+                            <a:srgbClr val="0F172A"/>
+                          </a:solidFill>
+                          <a:latin typeface="Segoe UI" pitchFamily="34" charset="0"/>
+                          <a:ea typeface="Segoe UI" pitchFamily="34" charset="-122"/>
+                          <a:cs typeface="Segoe UI" pitchFamily="34" charset="-120"/>
+                        </a:rPr>
+                        <a:t>Xong - đã deploy kèm tính năng</a:t>
+                      </a:r>
+                      <a:endParaRPr lang="en-US" sz="1050" dirty="0">
+                        <a:latin typeface="Segoe UI" charset="0"/>
+                        <a:ea typeface="Segoe UI" charset="0"/>
+                        <a:cs typeface="Segoe UI" charset="0"/>
+                      </a:endParaRPr>
+                    </a:p>
+                  </a:txBody>
+                  <a:tcPr marL="73152" marR="73152" marT="73152" marB="73152" anchor="ctr">
+                    <a:lnL w="9525" cap="flat" cmpd="sng" algn="ctr">
+                      <a:solidFill>
+                        <a:srgbClr val="E2E8F0"/>
+                      </a:solidFill>
+                      <a:prstDash val="solid"/>
+                      <a:round/>
+                      <a:headEnd type="none" w="med" len="med"/>
+                      <a:tailEnd type="none" w="med" len="med"/>
+                    </a:lnL>
+                    <a:lnR w="9525" cap="flat" cmpd="sng" algn="ctr">
+                      <a:solidFill>
+                        <a:srgbClr val="E2E8F0"/>
+                      </a:solidFill>
+                      <a:prstDash val="solid"/>
+                      <a:round/>
+                      <a:headEnd type="none" w="med" len="med"/>
+                      <a:tailEnd type="none" w="med" len="med"/>
+                    </a:lnR>
+                    <a:lnT w="9525" cap="flat" cmpd="sng" algn="ctr">
+                      <a:solidFill>
+                        <a:srgbClr val="E2E8F0"/>
+                      </a:solidFill>
+                      <a:prstDash val="solid"/>
+                      <a:round/>
+                      <a:headEnd type="none" w="med" len="med"/>
+                      <a:tailEnd type="none" w="med" len="med"/>
+                    </a:lnT>
+                    <a:lnB w="9525" cap="flat" cmpd="sng" algn="ctr">
+                      <a:solidFill>
+                        <a:srgbClr val="E2E8F0"/>
+                      </a:solidFill>
+                      <a:prstDash val="solid"/>
+                      <a:round/>
+                      <a:headEnd type="none" w="med" len="med"/>
+                      <a:tailEnd type="none" w="med" len="med"/>
+                    </a:lnB>
+                    <a:solidFill>
+                      <a:srgbClr val="FFFFFF"/>
                     </a:solidFill>
                   </a:tcPr>
                 </a:tc>
@@ -16611,7 +16943,7 @@
                       <a:tailEnd type="none" w="med" len="med"/>
                     </a:lnB>
                     <a:solidFill>
-                      <a:srgbClr val="FFFFFF"/>
+                      <a:srgbClr val="F8FAFC"/>
                     </a:solidFill>
                   </a:tcPr>
                 </a:tc>
@@ -16679,7 +17011,7 @@
                       <a:tailEnd type="none" w="med" len="med"/>
                     </a:lnB>
                     <a:solidFill>
-                      <a:srgbClr val="FFFFFF"/>
+                      <a:srgbClr val="F8FAFC"/>
                     </a:solidFill>
                   </a:tcPr>
                 </a:tc>
@@ -16747,7 +17079,7 @@
                       <a:tailEnd type="none" w="med" len="med"/>
                     </a:lnB>
                     <a:solidFill>
-                      <a:srgbClr val="FFFFFF"/>
+                      <a:srgbClr val="F8FAFC"/>
                     </a:solidFill>
                   </a:tcPr>
                 </a:tc>
@@ -16817,7 +17149,7 @@
                       <a:tailEnd type="none" w="med" len="med"/>
                     </a:lnB>
                     <a:solidFill>
-                      <a:srgbClr val="F8FAFC"/>
+                      <a:srgbClr val="FFFFFF"/>
                     </a:solidFill>
                   </a:tcPr>
                 </a:tc>
@@ -16885,7 +17217,7 @@
                       <a:tailEnd type="none" w="med" len="med"/>
                     </a:lnB>
                     <a:solidFill>
-                      <a:srgbClr val="F8FAFC"/>
+                      <a:srgbClr val="FFFFFF"/>
                     </a:solidFill>
                   </a:tcPr>
                 </a:tc>
@@ -16953,7 +17285,7 @@
                       <a:tailEnd type="none" w="med" len="med"/>
                     </a:lnB>
                     <a:solidFill>
-                      <a:srgbClr val="F8FAFC"/>
+                      <a:srgbClr val="FFFFFF"/>
                     </a:solidFill>
                   </a:tcPr>
                 </a:tc>
@@ -17023,7 +17355,7 @@
                       <a:tailEnd type="none" w="med" len="med"/>
                     </a:lnB>
                     <a:solidFill>
-                      <a:srgbClr val="FFFFFF"/>
+                      <a:srgbClr val="F8FAFC"/>
                     </a:solidFill>
                   </a:tcPr>
                 </a:tc>
@@ -17091,6 +17423,144 @@
                       <a:tailEnd type="none" w="med" len="med"/>
                     </a:lnB>
                     <a:solidFill>
+                      <a:srgbClr val="F8FAFC"/>
+                    </a:solidFill>
+                  </a:tcPr>
+                </a:tc>
+                <a:tc>
+                  <a:txBody>
+                    <a:bodyPr/>
+                    <a:lstStyle/>
+                    <a:p>
+                      <a:pPr indent="0" marL="0">
+                        <a:buNone/>
+                      </a:pPr>
+                      <a:r>
+                        <a:rPr lang="en-US" sz="1050" dirty="0">
+                          <a:solidFill>
+                            <a:srgbClr val="0F172A"/>
+                          </a:solidFill>
+                          <a:latin typeface="Segoe UI" pitchFamily="34" charset="0"/>
+                          <a:ea typeface="Segoe UI" pitchFamily="34" charset="-122"/>
+                          <a:cs typeface="Segoe UI" pitchFamily="34" charset="-120"/>
+                        </a:rPr>
+                        <a:t>Trung bình - đổi bên trong seam, giữ API</a:t>
+                      </a:r>
+                      <a:endParaRPr lang="en-US" sz="1050" dirty="0">
+                        <a:latin typeface="Segoe UI" charset="0"/>
+                        <a:ea typeface="Segoe UI" charset="0"/>
+                        <a:cs typeface="Segoe UI" charset="0"/>
+                      </a:endParaRPr>
+                    </a:p>
+                  </a:txBody>
+                  <a:tcPr marL="73152" marR="73152" marT="73152" marB="73152" anchor="ctr">
+                    <a:lnL w="9525" cap="flat" cmpd="sng" algn="ctr">
+                      <a:solidFill>
+                        <a:srgbClr val="E2E8F0"/>
+                      </a:solidFill>
+                      <a:prstDash val="solid"/>
+                      <a:round/>
+                      <a:headEnd type="none" w="med" len="med"/>
+                      <a:tailEnd type="none" w="med" len="med"/>
+                    </a:lnL>
+                    <a:lnR w="9525" cap="flat" cmpd="sng" algn="ctr">
+                      <a:solidFill>
+                        <a:srgbClr val="E2E8F0"/>
+                      </a:solidFill>
+                      <a:prstDash val="solid"/>
+                      <a:round/>
+                      <a:headEnd type="none" w="med" len="med"/>
+                      <a:tailEnd type="none" w="med" len="med"/>
+                    </a:lnR>
+                    <a:lnT w="9525" cap="flat" cmpd="sng" algn="ctr">
+                      <a:solidFill>
+                        <a:srgbClr val="E2E8F0"/>
+                      </a:solidFill>
+                      <a:prstDash val="solid"/>
+                      <a:round/>
+                      <a:headEnd type="none" w="med" len="med"/>
+                      <a:tailEnd type="none" w="med" len="med"/>
+                    </a:lnT>
+                    <a:lnB w="9525" cap="flat" cmpd="sng" algn="ctr">
+                      <a:solidFill>
+                        <a:srgbClr val="E2E8F0"/>
+                      </a:solidFill>
+                      <a:prstDash val="solid"/>
+                      <a:round/>
+                      <a:headEnd type="none" w="med" len="med"/>
+                      <a:tailEnd type="none" w="med" len="med"/>
+                    </a:lnB>
+                    <a:solidFill>
+                      <a:srgbClr val="F8FAFC"/>
+                    </a:solidFill>
+                  </a:tcPr>
+                </a:tc>
+              </a:tr>
+              <a:tr h="658368">
+                <a:tc>
+                  <a:txBody>
+                    <a:bodyPr/>
+                    <a:lstStyle/>
+                    <a:p>
+                      <a:pPr indent="0" marL="0">
+                        <a:buNone/>
+                      </a:pPr>
+                      <a:r>
+                        <a:rPr lang="en-US" sz="1050" dirty="0">
+                          <a:solidFill>
+                            <a:srgbClr val="0F172A"/>
+                          </a:solidFill>
+                          <a:latin typeface="Segoe UI" pitchFamily="34" charset="0"/>
+                          <a:ea typeface="Segoe UI" pitchFamily="34" charset="-122"/>
+                          <a:cs typeface="Segoe UI" pitchFamily="34" charset="-120"/>
+                        </a:rPr>
+                        <a:t>LMS chấm tự động: essay_pending vẫn cần GV chấm tay; gian lận thi cử online chưa có chống chéo nâng cao</a:t>
+                      </a:r>
+                      <a:endParaRPr lang="en-US" sz="1050" dirty="0">
+                        <a:latin typeface="Segoe UI" charset="0"/>
+                        <a:ea typeface="Segoe UI" charset="0"/>
+                        <a:cs typeface="Segoe UI" charset="0"/>
+                      </a:endParaRPr>
+                    </a:p>
+                  </a:txBody>
+                  <a:tcPr marL="73152" marR="73152" marT="73152" marB="73152" anchor="ctr">
+                    <a:lnL w="9525" cap="flat" cmpd="sng" algn="ctr">
+                      <a:solidFill>
+                        <a:srgbClr val="E2E8F0"/>
+                      </a:solidFill>
+                      <a:prstDash val="solid"/>
+                      <a:round/>
+                      <a:headEnd type="none" w="med" len="med"/>
+                      <a:tailEnd type="none" w="med" len="med"/>
+                    </a:lnL>
+                    <a:lnR w="9525" cap="flat" cmpd="sng" algn="ctr">
+                      <a:solidFill>
+                        <a:srgbClr val="E2E8F0"/>
+                      </a:solidFill>
+                      <a:prstDash val="solid"/>
+                      <a:round/>
+                      <a:headEnd type="none" w="med" len="med"/>
+                      <a:tailEnd type="none" w="med" len="med"/>
+                    </a:lnR>
+                    <a:lnT w="9525" cap="flat" cmpd="sng" algn="ctr">
+                      <a:solidFill>
+                        <a:srgbClr val="E2E8F0"/>
+                      </a:solidFill>
+                      <a:prstDash val="solid"/>
+                      <a:round/>
+                      <a:headEnd type="none" w="med" len="med"/>
+                      <a:tailEnd type="none" w="med" len="med"/>
+                    </a:lnT>
+                    <a:lnB w="9525" cap="flat" cmpd="sng" algn="ctr">
+                      <a:solidFill>
+                        <a:srgbClr val="E2E8F0"/>
+                      </a:solidFill>
+                      <a:prstDash val="solid"/>
+                      <a:round/>
+                      <a:headEnd type="none" w="med" len="med"/>
+                      <a:tailEnd type="none" w="med" len="med"/>
+                    </a:lnB>
+                    <a:solidFill>
                       <a:srgbClr val="FFFFFF"/>
                     </a:solidFill>
                   </a:tcPr>
@@ -17112,7 +17582,75 @@
                           <a:ea typeface="Segoe UI" pitchFamily="34" charset="-122"/>
                           <a:cs typeface="Segoe UI" pitchFamily="34" charset="-120"/>
                         </a:rPr>
-                        <a:t>Trung bình - đổi bên trong seam, giữ API</a:t>
+                        <a:t>Chấp nhận ở mức bài tập lớp học; nâng cấp: chống tab-switch, giám sát webcam nếu làm thi thật</a:t>
+                      </a:r>
+                      <a:endParaRPr lang="en-US" sz="1050" dirty="0">
+                        <a:latin typeface="Segoe UI" charset="0"/>
+                        <a:ea typeface="Segoe UI" charset="0"/>
+                        <a:cs typeface="Segoe UI" charset="0"/>
+                      </a:endParaRPr>
+                    </a:p>
+                  </a:txBody>
+                  <a:tcPr marL="73152" marR="73152" marT="73152" marB="73152" anchor="ctr">
+                    <a:lnL w="9525" cap="flat" cmpd="sng" algn="ctr">
+                      <a:solidFill>
+                        <a:srgbClr val="E2E8F0"/>
+                      </a:solidFill>
+                      <a:prstDash val="solid"/>
+                      <a:round/>
+                      <a:headEnd type="none" w="med" len="med"/>
+                      <a:tailEnd type="none" w="med" len="med"/>
+                    </a:lnL>
+                    <a:lnR w="9525" cap="flat" cmpd="sng" algn="ctr">
+                      <a:solidFill>
+                        <a:srgbClr val="E2E8F0"/>
+                      </a:solidFill>
+                      <a:prstDash val="solid"/>
+                      <a:round/>
+                      <a:headEnd type="none" w="med" len="med"/>
+                      <a:tailEnd type="none" w="med" len="med"/>
+                    </a:lnR>
+                    <a:lnT w="9525" cap="flat" cmpd="sng" algn="ctr">
+                      <a:solidFill>
+                        <a:srgbClr val="E2E8F0"/>
+                      </a:solidFill>
+                      <a:prstDash val="solid"/>
+                      <a:round/>
+                      <a:headEnd type="none" w="med" len="med"/>
+                      <a:tailEnd type="none" w="med" len="med"/>
+                    </a:lnT>
+                    <a:lnB w="9525" cap="flat" cmpd="sng" algn="ctr">
+                      <a:solidFill>
+                        <a:srgbClr val="E2E8F0"/>
+                      </a:solidFill>
+                      <a:prstDash val="solid"/>
+                      <a:round/>
+                      <a:headEnd type="none" w="med" len="med"/>
+                      <a:tailEnd type="none" w="med" len="med"/>
+                    </a:lnB>
+                    <a:solidFill>
+                      <a:srgbClr val="FFFFFF"/>
+                    </a:solidFill>
+                  </a:tcPr>
+                </a:tc>
+                <a:tc>
+                  <a:txBody>
+                    <a:bodyPr/>
+                    <a:lstStyle/>
+                    <a:p>
+                      <a:pPr indent="0" marL="0">
+                        <a:buNone/>
+                      </a:pPr>
+                      <a:r>
+                        <a:rPr lang="en-US" sz="1050" dirty="0">
+                          <a:solidFill>
+                            <a:srgbClr val="0F172A"/>
+                          </a:solidFill>
+                          <a:latin typeface="Segoe UI" pitchFamily="34" charset="0"/>
+                          <a:ea typeface="Segoe UI" pitchFamily="34" charset="-122"/>
+                          <a:cs typeface="Segoe UI" pitchFamily="34" charset="-120"/>
+                        </a:rPr>
+                        <a:t>Trung bình - tính năng mới, chưa phải lỗi</a:t>
                       </a:r>
                       <a:endParaRPr lang="en-US" sz="1050" dirty="0">
                         <a:latin typeface="Segoe UI" charset="0"/>
@@ -18611,6 +19149,282 @@
                           <a:ea typeface="Segoe UI" pitchFamily="34" charset="-122"/>
                           <a:cs typeface="Segoe UI" pitchFamily="34" charset="-120"/>
                         </a:rPr>
+                        <a:t>Bán theo gói cho trường</a:t>
+                      </a:r>
+                      <a:endParaRPr lang="en-US" sz="1050" dirty="0">
+                        <a:latin typeface="Segoe UI" charset="0"/>
+                        <a:ea typeface="Segoe UI" charset="0"/>
+                        <a:cs typeface="Segoe UI" charset="0"/>
+                      </a:endParaRPr>
+                    </a:p>
+                  </a:txBody>
+                  <a:tcPr marL="73152" marR="73152" marT="73152" marB="73152" anchor="ctr">
+                    <a:lnL w="9525" cap="flat" cmpd="sng" algn="ctr">
+                      <a:solidFill>
+                        <a:srgbClr val="E2E8F0"/>
+                      </a:solidFill>
+                      <a:prstDash val="solid"/>
+                      <a:round/>
+                      <a:headEnd type="none" w="med" len="med"/>
+                      <a:tailEnd type="none" w="med" len="med"/>
+                    </a:lnL>
+                    <a:lnR w="9525" cap="flat" cmpd="sng" algn="ctr">
+                      <a:solidFill>
+                        <a:srgbClr val="E2E8F0"/>
+                      </a:solidFill>
+                      <a:prstDash val="solid"/>
+                      <a:round/>
+                      <a:headEnd type="none" w="med" len="med"/>
+                      <a:tailEnd type="none" w="med" len="med"/>
+                    </a:lnR>
+                    <a:lnT w="9525" cap="flat" cmpd="sng" algn="ctr">
+                      <a:solidFill>
+                        <a:srgbClr val="E2E8F0"/>
+                      </a:solidFill>
+                      <a:prstDash val="solid"/>
+                      <a:round/>
+                      <a:headEnd type="none" w="med" len="med"/>
+                      <a:tailEnd type="none" w="med" len="med"/>
+                    </a:lnT>
+                    <a:lnB w="9525" cap="flat" cmpd="sng" algn="ctr">
+                      <a:solidFill>
+                        <a:srgbClr val="E2E8F0"/>
+                      </a:solidFill>
+                      <a:prstDash val="solid"/>
+                      <a:round/>
+                      <a:headEnd type="none" w="med" len="med"/>
+                      <a:tailEnd type="none" w="med" len="med"/>
+                    </a:lnB>
+                    <a:solidFill>
+                      <a:srgbClr val="FFFFFF"/>
+                    </a:solidFill>
+                  </a:tcPr>
+                </a:tc>
+                <a:tc>
+                  <a:txBody>
+                    <a:bodyPr/>
+                    <a:lstStyle/>
+                    <a:p>
+                      <a:pPr indent="0" marL="0">
+                        <a:buNone/>
+                      </a:pPr>
+                      <a:r>
+                        <a:rPr lang="en-US" sz="1050" dirty="0">
+                          <a:solidFill>
+                            <a:srgbClr val="0F172A"/>
+                          </a:solidFill>
+                          <a:latin typeface="Segoe UI" pitchFamily="34" charset="0"/>
+                          <a:ea typeface="Segoe UI" pitchFamily="34" charset="-122"/>
+                          <a:cs typeface="Segoe UI" pitchFamily="34" charset="-120"/>
+                        </a:rPr>
+                        <a:t>school_features + gating 4 lớp - feature flags ở tầng kiến trúc, không phải if-else UI</a:t>
+                      </a:r>
+                      <a:endParaRPr lang="en-US" sz="1050" dirty="0">
+                        <a:latin typeface="Segoe UI" charset="0"/>
+                        <a:ea typeface="Segoe UI" charset="0"/>
+                        <a:cs typeface="Segoe UI" charset="0"/>
+                      </a:endParaRPr>
+                    </a:p>
+                  </a:txBody>
+                  <a:tcPr marL="73152" marR="73152" marT="73152" marB="73152" anchor="ctr">
+                    <a:lnL w="9525" cap="flat" cmpd="sng" algn="ctr">
+                      <a:solidFill>
+                        <a:srgbClr val="E2E8F0"/>
+                      </a:solidFill>
+                      <a:prstDash val="solid"/>
+                      <a:round/>
+                      <a:headEnd type="none" w="med" len="med"/>
+                      <a:tailEnd type="none" w="med" len="med"/>
+                    </a:lnL>
+                    <a:lnR w="9525" cap="flat" cmpd="sng" algn="ctr">
+                      <a:solidFill>
+                        <a:srgbClr val="E2E8F0"/>
+                      </a:solidFill>
+                      <a:prstDash val="solid"/>
+                      <a:round/>
+                      <a:headEnd type="none" w="med" len="med"/>
+                      <a:tailEnd type="none" w="med" len="med"/>
+                    </a:lnR>
+                    <a:lnT w="9525" cap="flat" cmpd="sng" algn="ctr">
+                      <a:solidFill>
+                        <a:srgbClr val="E2E8F0"/>
+                      </a:solidFill>
+                      <a:prstDash val="solid"/>
+                      <a:round/>
+                      <a:headEnd type="none" w="med" len="med"/>
+                      <a:tailEnd type="none" w="med" len="med"/>
+                    </a:lnT>
+                    <a:lnB w="9525" cap="flat" cmpd="sng" algn="ctr">
+                      <a:solidFill>
+                        <a:srgbClr val="E2E8F0"/>
+                      </a:solidFill>
+                      <a:prstDash val="solid"/>
+                      <a:round/>
+                      <a:headEnd type="none" w="med" len="med"/>
+                      <a:tailEnd type="none" w="med" len="med"/>
+                    </a:lnB>
+                    <a:solidFill>
+                      <a:srgbClr val="FFFFFF"/>
+                    </a:solidFill>
+                  </a:tcPr>
+                </a:tc>
+              </a:tr>
+              <a:tr h="512064">
+                <a:tc>
+                  <a:txBody>
+                    <a:bodyPr/>
+                    <a:lstStyle/>
+                    <a:p>
+                      <a:pPr indent="0" marL="0">
+                        <a:buNone/>
+                      </a:pPr>
+                      <a:r>
+                        <a:rPr lang="en-US" sz="1050" dirty="0">
+                          <a:solidFill>
+                            <a:srgbClr val="0F172A"/>
+                          </a:solidFill>
+                          <a:latin typeface="Segoe UI" pitchFamily="34" charset="0"/>
+                          <a:ea typeface="Segoe UI" pitchFamily="34" charset="-122"/>
+                          <a:cs typeface="Segoe UI" pitchFamily="34" charset="-120"/>
+                        </a:rPr>
+                        <a:t>Cổng public cho phụ huynh tuyển sinh</a:t>
+                      </a:r>
+                      <a:endParaRPr lang="en-US" sz="1050" dirty="0">
+                        <a:latin typeface="Segoe UI" charset="0"/>
+                        <a:ea typeface="Segoe UI" charset="0"/>
+                        <a:cs typeface="Segoe UI" charset="0"/>
+                      </a:endParaRPr>
+                    </a:p>
+                  </a:txBody>
+                  <a:tcPr marL="73152" marR="73152" marT="73152" marB="73152" anchor="ctr">
+                    <a:lnL w="9525" cap="flat" cmpd="sng" algn="ctr">
+                      <a:solidFill>
+                        <a:srgbClr val="E2E8F0"/>
+                      </a:solidFill>
+                      <a:prstDash val="solid"/>
+                      <a:round/>
+                      <a:headEnd type="none" w="med" len="med"/>
+                      <a:tailEnd type="none" w="med" len="med"/>
+                    </a:lnL>
+                    <a:lnR w="9525" cap="flat" cmpd="sng" algn="ctr">
+                      <a:solidFill>
+                        <a:srgbClr val="E2E8F0"/>
+                      </a:solidFill>
+                      <a:prstDash val="solid"/>
+                      <a:round/>
+                      <a:headEnd type="none" w="med" len="med"/>
+                      <a:tailEnd type="none" w="med" len="med"/>
+                    </a:lnR>
+                    <a:lnT w="9525" cap="flat" cmpd="sng" algn="ctr">
+                      <a:solidFill>
+                        <a:srgbClr val="E2E8F0"/>
+                      </a:solidFill>
+                      <a:prstDash val="solid"/>
+                      <a:round/>
+                      <a:headEnd type="none" w="med" len="med"/>
+                      <a:tailEnd type="none" w="med" len="med"/>
+                    </a:lnT>
+                    <a:lnB w="9525" cap="flat" cmpd="sng" algn="ctr">
+                      <a:solidFill>
+                        <a:srgbClr val="E2E8F0"/>
+                      </a:solidFill>
+                      <a:prstDash val="solid"/>
+                      <a:round/>
+                      <a:headEnd type="none" w="med" len="med"/>
+                      <a:tailEnd type="none" w="med" len="med"/>
+                    </a:lnB>
+                    <a:solidFill>
+                      <a:srgbClr val="F8FAFC"/>
+                    </a:solidFill>
+                  </a:tcPr>
+                </a:tc>
+                <a:tc>
+                  <a:txBody>
+                    <a:bodyPr/>
+                    <a:lstStyle/>
+                    <a:p>
+                      <a:pPr indent="0" marL="0">
+                        <a:buNone/>
+                      </a:pPr>
+                      <a:r>
+                        <a:rPr lang="en-US" sz="1050" dirty="0">
+                          <a:solidFill>
+                            <a:srgbClr val="0F172A"/>
+                          </a:solidFill>
+                          <a:latin typeface="Segoe UI" pitchFamily="34" charset="0"/>
+                          <a:ea typeface="Segoe UI" pitchFamily="34" charset="-122"/>
+                          <a:cs typeface="Segoe UI" pitchFamily="34" charset="-120"/>
+                        </a:rPr>
+                        <a:t>Route /apply ngoài auth + Turnstile + RPC-only writes - public không đồng nghĩa mở toang</a:t>
+                      </a:r>
+                      <a:endParaRPr lang="en-US" sz="1050" dirty="0">
+                        <a:latin typeface="Segoe UI" charset="0"/>
+                        <a:ea typeface="Segoe UI" charset="0"/>
+                        <a:cs typeface="Segoe UI" charset="0"/>
+                      </a:endParaRPr>
+                    </a:p>
+                  </a:txBody>
+                  <a:tcPr marL="73152" marR="73152" marT="73152" marB="73152" anchor="ctr">
+                    <a:lnL w="9525" cap="flat" cmpd="sng" algn="ctr">
+                      <a:solidFill>
+                        <a:srgbClr val="E2E8F0"/>
+                      </a:solidFill>
+                      <a:prstDash val="solid"/>
+                      <a:round/>
+                      <a:headEnd type="none" w="med" len="med"/>
+                      <a:tailEnd type="none" w="med" len="med"/>
+                    </a:lnL>
+                    <a:lnR w="9525" cap="flat" cmpd="sng" algn="ctr">
+                      <a:solidFill>
+                        <a:srgbClr val="E2E8F0"/>
+                      </a:solidFill>
+                      <a:prstDash val="solid"/>
+                      <a:round/>
+                      <a:headEnd type="none" w="med" len="med"/>
+                      <a:tailEnd type="none" w="med" len="med"/>
+                    </a:lnR>
+                    <a:lnT w="9525" cap="flat" cmpd="sng" algn="ctr">
+                      <a:solidFill>
+                        <a:srgbClr val="E2E8F0"/>
+                      </a:solidFill>
+                      <a:prstDash val="solid"/>
+                      <a:round/>
+                      <a:headEnd type="none" w="med" len="med"/>
+                      <a:tailEnd type="none" w="med" len="med"/>
+                    </a:lnT>
+                    <a:lnB w="9525" cap="flat" cmpd="sng" algn="ctr">
+                      <a:solidFill>
+                        <a:srgbClr val="E2E8F0"/>
+                      </a:solidFill>
+                      <a:prstDash val="solid"/>
+                      <a:round/>
+                      <a:headEnd type="none" w="med" len="med"/>
+                      <a:tailEnd type="none" w="med" len="med"/>
+                    </a:lnB>
+                    <a:solidFill>
+                      <a:srgbClr val="F8FAFC"/>
+                    </a:solidFill>
+                  </a:tcPr>
+                </a:tc>
+              </a:tr>
+              <a:tr h="512064">
+                <a:tc>
+                  <a:txBody>
+                    <a:bodyPr/>
+                    <a:lstStyle/>
+                    <a:p>
+                      <a:pPr indent="0" marL="0">
+                        <a:buNone/>
+                      </a:pPr>
+                      <a:r>
+                        <a:rPr lang="en-US" sz="1050" dirty="0">
+                          <a:solidFill>
+                            <a:srgbClr val="0F172A"/>
+                          </a:solidFill>
+                          <a:latin typeface="Segoe UI" pitchFamily="34" charset="0"/>
+                          <a:ea typeface="Segoe UI" pitchFamily="34" charset="-122"/>
+                          <a:cs typeface="Segoe UI" pitchFamily="34" charset="-120"/>
+                        </a:rPr>
                         <a:t>Xuất tài liệu hành chính</a:t>
                       </a:r>
                       <a:endParaRPr lang="en-US" sz="1050" dirty="0">
@@ -18947,7 +19761,7 @@
                 <a:ea typeface="Segoe UI" pitchFamily="34" charset="-122"/>
                 <a:cs typeface="Segoe UI" pitchFamily="34" charset="-120"/>
               </a:rPr>
-              <a:t>RLS biến yêu cầu khó nhất (phân quyền đa vai trò) thành thế mạnh; 1 Postgres giữ nhất quán mà không cần saga</a:t>
+              <a:t>RLS biến yêu cầu khó nhất (phân quyền đa vai trò) thành thế mạnh; 1 Postgres giữ nhất quán mà không cần saga - kể cả chuỗi tuyển sinh -&gt; nhập học -&gt; thu phí -&gt; học bạ</a:t>
             </a:r>
             <a:endParaRPr lang="en-US" sz="1350" dirty="0"/>
           </a:p>
@@ -18968,7 +19782,28 @@
                 <a:ea typeface="Segoe UI" pitchFamily="34" charset="-122"/>
                 <a:cs typeface="Segoe UI" pitchFamily="34" charset="-120"/>
               </a:rPr>
-              <a:t>Không broker/Redis vì chưa có số đo đòi hỏi - seams (ai_jobs, cron, route groups) đã đặt sẵn để thêm khi scale chứng minh cần</a:t>
+              <a:t>Module flags (school_features) đưa 'bán theo gói' xuống tầng kiến trúc: tắt flag = nav + route + RPC + RLS cùng tắt</a:t>
+            </a:r>
+            <a:endParaRPr lang="en-US" sz="1350" dirty="0"/>
+          </a:p>
+          <a:p>
+            <a:pPr marL="177800" indent="-177800">
+              <a:spcAft>
+                <a:spcPts val="800"/>
+              </a:spcAft>
+              <a:buSzPct val="100000"/>
+              <a:buChar char="•"/>
+            </a:pPr>
+            <a:r>
+              <a:rPr lang="en-US" sz="1350" dirty="0">
+                <a:solidFill>
+                  <a:srgbClr val="FFFFFF"/>
+                </a:solidFill>
+                <a:latin typeface="Segoe UI" pitchFamily="34" charset="0"/>
+                <a:ea typeface="Segoe UI" pitchFamily="34" charset="-122"/>
+                <a:cs typeface="Segoe UI" pitchFamily="34" charset="-120"/>
+              </a:rPr>
+              <a:t>Không broker/Redis vì chưa có số đo đòi hỏi - seams (ai_jobs, cron, route groups, schema-per-app) đã đặt sẵn để thêm khi scale chứng minh cần</a:t>
             </a:r>
             <a:endParaRPr lang="en-US" sz="1350" dirty="0"/>
           </a:p>
@@ -19028,7 +19863,7 @@
                 <a:ea typeface="Segoe UI" pitchFamily="34" charset="-122"/>
                 <a:cs typeface="Segoe UI" pitchFamily="34" charset="-120"/>
               </a:rPr>
-              <a:t>Tài liệu kèm: USER-GUIDE-vieschool.pptx (38 slides, 10 vai trò) - docs/project/ARCHITECTURE.md (chi tiết kỹ thuật)</a:t>
+              <a:t>Tài liệu kèm: USER-GUIDE-vieschool.pptx (43 slides, 10 vai trò + module mở rộng) - docs/project/ARCHITECTURE.md (chi tiết kỹ thuật)</a:t>
             </a:r>
             <a:endParaRPr lang="en-US" sz="1100" dirty="0"/>
           </a:p>
@@ -19695,7 +20530,24 @@
                 <a:ea typeface="Segoe UI" pitchFamily="34" charset="-122"/>
                 <a:cs typeface="Segoe UI" pitchFamily="34" charset="-120"/>
               </a:rPr>
-              <a:t>Postgres ~30+ bảng</a:t>
+              <a:t>public: 86 bảng SCN</a:t>
+            </a:r>
+            <a:endParaRPr lang="en-US" sz="1000" dirty="0"/>
+          </a:p>
+          <a:p>
+            <a:pPr algn="ctr" indent="0" marL="0">
+              <a:buNone/>
+            </a:pPr>
+            <a:r>
+              <a:rPr lang="en-US" sz="1000" dirty="0">
+                <a:solidFill>
+                  <a:srgbClr val="475569"/>
+                </a:solidFill>
+                <a:latin typeface="Segoe UI" pitchFamily="34" charset="0"/>
+                <a:ea typeface="Segoe UI" pitchFamily="34" charset="-122"/>
+                <a:cs typeface="Segoe UI" pitchFamily="34" charset="-120"/>
+              </a:rPr>
+              <a:t>+ 3 schema app khác</a:t>
             </a:r>
             <a:endParaRPr lang="en-US" sz="1000" dirty="0"/>
           </a:p>
@@ -19713,23 +20565,6 @@
                 <a:cs typeface="Segoe UI" pitchFamily="34" charset="-120"/>
               </a:rPr>
               <a:t>RLS mọi bảng tenant</a:t>
-            </a:r>
-            <a:endParaRPr lang="en-US" sz="1000" dirty="0"/>
-          </a:p>
-          <a:p>
-            <a:pPr algn="ctr" indent="0" marL="0">
-              <a:buNone/>
-            </a:pPr>
-            <a:r>
-              <a:rPr lang="en-US" sz="1000" dirty="0">
-                <a:solidFill>
-                  <a:srgbClr val="475569"/>
-                </a:solidFill>
-                <a:latin typeface="Segoe UI" pitchFamily="34" charset="0"/>
-                <a:ea typeface="Segoe UI" pitchFamily="34" charset="-122"/>
-                <a:cs typeface="Segoe UI" pitchFamily="34" charset="-120"/>
-              </a:rPr>
-              <a:t>Auth email/password</a:t>
             </a:r>
             <a:endParaRPr lang="en-US" sz="1000" dirty="0"/>
           </a:p>
@@ -19990,7 +20825,28 @@
                 <a:ea typeface="Segoe UI" pitchFamily="34" charset="-122"/>
                 <a:cs typeface="Segoe UI" pitchFamily="34" charset="-120"/>
               </a:rPr>
-              <a:t>Supabase project chung với một sản phẩm nội bộ khác - tách biệt bằng RLS, không phải DB riêng</a:t>
+              <a:t>Cùng Supabase project có 3 schema của các app nội bộ khác - cô lập bằng schema + RLS; SCN chiếm schema public (86 bảng)</a:t>
+            </a:r>
+            <a:endParaRPr lang="en-US" sz="1250" dirty="0"/>
+          </a:p>
+          <a:p>
+            <a:pPr marL="177800" indent="-177800">
+              <a:spcAft>
+                <a:spcPts val="800"/>
+              </a:spcAft>
+              <a:buSzPct val="100000"/>
+              <a:buChar char="•"/>
+            </a:pPr>
+            <a:r>
+              <a:rPr lang="en-US" sz="1250" dirty="0">
+                <a:solidFill>
+                  <a:srgbClr val="0F172A"/>
+                </a:solidFill>
+                <a:latin typeface="Segoe UI" pitchFamily="34" charset="0"/>
+                <a:ea typeface="Segoe UI" pitchFamily="34" charset="-122"/>
+                <a:cs typeface="Segoe UI" pitchFamily="34" charset="-120"/>
+              </a:rPr>
+              <a:t>Surface public duy nhất: /apply (tuyển sinh, không cần login) - Turnstile + revoke anon + RPC security-definer</a:t>
             </a:r>
             <a:endParaRPr lang="en-US" sz="1250" dirty="0"/>
           </a:p>
@@ -22655,6 +23511,27 @@
                 <a:ea typeface="Segoe UI" pitchFamily="34" charset="-122"/>
                 <a:cs typeface="Segoe UI" pitchFamily="34" charset="-120"/>
               </a:rPr>
+              <a:t>Lớp 2.5 - schoolFeature(module): trường tắt module thì nav mất + route redirect + RPC trả module_disabled + RLS chặn (CR-060)</a:t>
+            </a:r>
+            <a:endParaRPr lang="en-US" sz="1150" dirty="0"/>
+          </a:p>
+          <a:p>
+            <a:pPr marL="177800" indent="-177800">
+              <a:spcAft>
+                <a:spcPts val="800"/>
+              </a:spcAft>
+              <a:buSzPct val="100000"/>
+              <a:buChar char="•"/>
+            </a:pPr>
+            <a:r>
+              <a:rPr lang="en-US" sz="1150" dirty="0">
+                <a:solidFill>
+                  <a:srgbClr val="0F172A"/>
+                </a:solidFill>
+                <a:latin typeface="Segoe UI" pitchFamily="34" charset="0"/>
+                <a:ea typeface="Segoe UI" pitchFamily="34" charset="-122"/>
+                <a:cs typeface="Segoe UI" pitchFamily="34" charset="-120"/>
+              </a:rPr>
               <a:t>WAF Vercel: rate limit /api + /login, bypass-health cho uptime monitor; headers CSP/HSTS/nosniff/X-Frame đầy đủ</a:t>
             </a:r>
             <a:endParaRPr lang="en-US" sz="1150" dirty="0"/>
@@ -22676,7 +23553,7 @@
                 <a:ea typeface="Segoe UI" pitchFamily="34" charset="-122"/>
                 <a:cs typeface="Segoe UI" pitchFamily="34" charset="-120"/>
               </a:rPr>
-              <a:t>Anti-scraping lớp 1 (CR-054, đã deploy): robots.txt chặn AI crawler, noindex route authed, export cap 20/h/uid, Turnstile login</a:t>
+              <a:t>Anti-scraping (CR-054): robots.txt chặn AI crawler, noindex route authed, export cap 20/h/uid; Turnstile login + /apply public</a:t>
             </a:r>
             <a:endParaRPr lang="en-US" sz="1150" dirty="0"/>
           </a:p>
@@ -23170,7 +24047,7 @@
                 <a:gridCol w="3657600"/>
                 <a:gridCol w="3657600"/>
               </a:tblGrid>
-              <a:tr h="420624">
+              <a:tr h="384048">
                 <a:tc>
                   <a:txBody>
                     <a:bodyPr/>
@@ -23376,7 +24253,7 @@
                   </a:tcPr>
                 </a:tc>
               </a:tr>
-              <a:tr h="420624">
+              <a:tr h="384048">
                 <a:tc>
                   <a:txBody>
                     <a:bodyPr/>
@@ -23582,7 +24459,7 @@
                   </a:tcPr>
                 </a:tc>
               </a:tr>
-              <a:tr h="420624">
+              <a:tr h="384048">
                 <a:tc>
                   <a:txBody>
                     <a:bodyPr/>
@@ -23788,7 +24665,7 @@
                   </a:tcPr>
                 </a:tc>
               </a:tr>
-              <a:tr h="420624">
+              <a:tr h="384048">
                 <a:tc>
                   <a:txBody>
                     <a:bodyPr/>
@@ -23994,7 +24871,7 @@
                   </a:tcPr>
                 </a:tc>
               </a:tr>
-              <a:tr h="420624">
+              <a:tr h="384048">
                 <a:tc>
                   <a:txBody>
                     <a:bodyPr/>
@@ -24200,7 +25077,7 @@
                   </a:tcPr>
                 </a:tc>
               </a:tr>
-              <a:tr h="420624">
+              <a:tr h="384048">
                 <a:tc>
                   <a:txBody>
                     <a:bodyPr/>
@@ -24406,7 +25283,7 @@
                   </a:tcPr>
                 </a:tc>
               </a:tr>
-              <a:tr h="420624">
+              <a:tr h="384048">
                 <a:tc>
                   <a:txBody>
                     <a:bodyPr/>
@@ -24612,7 +25489,1037 @@
                   </a:tcPr>
                 </a:tc>
               </a:tr>
-              <a:tr h="420624">
+              <a:tr h="384048">
+                <a:tc>
+                  <a:txBody>
+                    <a:bodyPr/>
+                    <a:lstStyle/>
+                    <a:p>
+                      <a:pPr indent="0" marL="0">
+                        <a:buNone/>
+                      </a:pPr>
+                      <a:r>
+                        <a:rPr lang="en-US" sz="1050" dirty="0">
+                          <a:solidFill>
+                            <a:srgbClr val="0F172A"/>
+                          </a:solidFill>
+                          <a:latin typeface="Segoe UI" pitchFamily="34" charset="0"/>
+                          <a:ea typeface="Segoe UI" pitchFamily="34" charset="-122"/>
+                          <a:cs typeface="Segoe UI" pitchFamily="34" charset="-120"/>
+                        </a:rPr>
+                        <a:t>Tuyển sinh</a:t>
+                      </a:r>
+                      <a:endParaRPr lang="en-US" sz="1050" dirty="0">
+                        <a:latin typeface="Segoe UI" charset="0"/>
+                        <a:ea typeface="Segoe UI" charset="0"/>
+                        <a:cs typeface="Segoe UI" charset="0"/>
+                      </a:endParaRPr>
+                    </a:p>
+                  </a:txBody>
+                  <a:tcPr marL="73152" marR="73152" marT="73152" marB="73152" anchor="ctr">
+                    <a:lnL w="9525" cap="flat" cmpd="sng" algn="ctr">
+                      <a:solidFill>
+                        <a:srgbClr val="E2E8F0"/>
+                      </a:solidFill>
+                      <a:prstDash val="solid"/>
+                      <a:round/>
+                      <a:headEnd type="none" w="med" len="med"/>
+                      <a:tailEnd type="none" w="med" len="med"/>
+                    </a:lnL>
+                    <a:lnR w="9525" cap="flat" cmpd="sng" algn="ctr">
+                      <a:solidFill>
+                        <a:srgbClr val="E2E8F0"/>
+                      </a:solidFill>
+                      <a:prstDash val="solid"/>
+                      <a:round/>
+                      <a:headEnd type="none" w="med" len="med"/>
+                      <a:tailEnd type="none" w="med" len="med"/>
+                    </a:lnR>
+                    <a:lnT w="9525" cap="flat" cmpd="sng" algn="ctr">
+                      <a:solidFill>
+                        <a:srgbClr val="E2E8F0"/>
+                      </a:solidFill>
+                      <a:prstDash val="solid"/>
+                      <a:round/>
+                      <a:headEnd type="none" w="med" len="med"/>
+                      <a:tailEnd type="none" w="med" len="med"/>
+                    </a:lnT>
+                    <a:lnB w="9525" cap="flat" cmpd="sng" algn="ctr">
+                      <a:solidFill>
+                        <a:srgbClr val="E2E8F0"/>
+                      </a:solidFill>
+                      <a:prstDash val="solid"/>
+                      <a:round/>
+                      <a:headEnd type="none" w="med" len="med"/>
+                      <a:tailEnd type="none" w="med" len="med"/>
+                    </a:lnB>
+                    <a:solidFill>
+                      <a:srgbClr val="FFFFFF"/>
+                    </a:solidFill>
+                  </a:tcPr>
+                </a:tc>
+                <a:tc>
+                  <a:txBody>
+                    <a:bodyPr/>
+                    <a:lstStyle/>
+                    <a:p>
+                      <a:pPr indent="0" marL="0">
+                        <a:buNone/>
+                      </a:pPr>
+                      <a:r>
+                        <a:rPr lang="en-US" sz="1050" dirty="0">
+                          <a:solidFill>
+                            <a:srgbClr val="0F172A"/>
+                          </a:solidFill>
+                          <a:latin typeface="Segoe UI" pitchFamily="34" charset="0"/>
+                          <a:ea typeface="Segoe UI" pitchFamily="34" charset="-122"/>
+                          <a:cs typeface="Segoe UI" pitchFamily="34" charset="-120"/>
+                        </a:rPr>
+                        <a:t>school/admissions/, apply/ (public)</a:t>
+                      </a:r>
+                      <a:endParaRPr lang="en-US" sz="1050" dirty="0">
+                        <a:latin typeface="Segoe UI" charset="0"/>
+                        <a:ea typeface="Segoe UI" charset="0"/>
+                        <a:cs typeface="Segoe UI" charset="0"/>
+                      </a:endParaRPr>
+                    </a:p>
+                  </a:txBody>
+                  <a:tcPr marL="73152" marR="73152" marT="73152" marB="73152" anchor="ctr">
+                    <a:lnL w="9525" cap="flat" cmpd="sng" algn="ctr">
+                      <a:solidFill>
+                        <a:srgbClr val="E2E8F0"/>
+                      </a:solidFill>
+                      <a:prstDash val="solid"/>
+                      <a:round/>
+                      <a:headEnd type="none" w="med" len="med"/>
+                      <a:tailEnd type="none" w="med" len="med"/>
+                    </a:lnL>
+                    <a:lnR w="9525" cap="flat" cmpd="sng" algn="ctr">
+                      <a:solidFill>
+                        <a:srgbClr val="E2E8F0"/>
+                      </a:solidFill>
+                      <a:prstDash val="solid"/>
+                      <a:round/>
+                      <a:headEnd type="none" w="med" len="med"/>
+                      <a:tailEnd type="none" w="med" len="med"/>
+                    </a:lnR>
+                    <a:lnT w="9525" cap="flat" cmpd="sng" algn="ctr">
+                      <a:solidFill>
+                        <a:srgbClr val="E2E8F0"/>
+                      </a:solidFill>
+                      <a:prstDash val="solid"/>
+                      <a:round/>
+                      <a:headEnd type="none" w="med" len="med"/>
+                      <a:tailEnd type="none" w="med" len="med"/>
+                    </a:lnT>
+                    <a:lnB w="9525" cap="flat" cmpd="sng" algn="ctr">
+                      <a:solidFill>
+                        <a:srgbClr val="E2E8F0"/>
+                      </a:solidFill>
+                      <a:prstDash val="solid"/>
+                      <a:round/>
+                      <a:headEnd type="none" w="med" len="med"/>
+                      <a:tailEnd type="none" w="med" len="med"/>
+                    </a:lnB>
+                    <a:solidFill>
+                      <a:srgbClr val="FFFFFF"/>
+                    </a:solidFill>
+                  </a:tcPr>
+                </a:tc>
+                <a:tc>
+                  <a:txBody>
+                    <a:bodyPr/>
+                    <a:lstStyle/>
+                    <a:p>
+                      <a:pPr indent="0" marL="0">
+                        <a:buNone/>
+                      </a:pPr>
+                      <a:r>
+                        <a:rPr lang="en-US" sz="1050" dirty="0">
+                          <a:solidFill>
+                            <a:srgbClr val="0F172A"/>
+                          </a:solidFill>
+                          <a:latin typeface="Segoe UI" pitchFamily="34" charset="0"/>
+                          <a:ea typeface="Segoe UI" pitchFamily="34" charset="-122"/>
+                          <a:cs typeface="Segoe UI" pitchFamily="34" charset="-120"/>
+                        </a:rPr>
+                        <a:t>admission_campaigns, applications</a:t>
+                      </a:r>
+                      <a:endParaRPr lang="en-US" sz="1050" dirty="0">
+                        <a:latin typeface="Segoe UI" charset="0"/>
+                        <a:ea typeface="Segoe UI" charset="0"/>
+                        <a:cs typeface="Segoe UI" charset="0"/>
+                      </a:endParaRPr>
+                    </a:p>
+                  </a:txBody>
+                  <a:tcPr marL="73152" marR="73152" marT="73152" marB="73152" anchor="ctr">
+                    <a:lnL w="9525" cap="flat" cmpd="sng" algn="ctr">
+                      <a:solidFill>
+                        <a:srgbClr val="E2E8F0"/>
+                      </a:solidFill>
+                      <a:prstDash val="solid"/>
+                      <a:round/>
+                      <a:headEnd type="none" w="med" len="med"/>
+                      <a:tailEnd type="none" w="med" len="med"/>
+                    </a:lnL>
+                    <a:lnR w="9525" cap="flat" cmpd="sng" algn="ctr">
+                      <a:solidFill>
+                        <a:srgbClr val="E2E8F0"/>
+                      </a:solidFill>
+                      <a:prstDash val="solid"/>
+                      <a:round/>
+                      <a:headEnd type="none" w="med" len="med"/>
+                      <a:tailEnd type="none" w="med" len="med"/>
+                    </a:lnR>
+                    <a:lnT w="9525" cap="flat" cmpd="sng" algn="ctr">
+                      <a:solidFill>
+                        <a:srgbClr val="E2E8F0"/>
+                      </a:solidFill>
+                      <a:prstDash val="solid"/>
+                      <a:round/>
+                      <a:headEnd type="none" w="med" len="med"/>
+                      <a:tailEnd type="none" w="med" len="med"/>
+                    </a:lnT>
+                    <a:lnB w="9525" cap="flat" cmpd="sng" algn="ctr">
+                      <a:solidFill>
+                        <a:srgbClr val="E2E8F0"/>
+                      </a:solidFill>
+                      <a:prstDash val="solid"/>
+                      <a:round/>
+                      <a:headEnd type="none" w="med" len="med"/>
+                      <a:tailEnd type="none" w="med" len="med"/>
+                    </a:lnB>
+                    <a:solidFill>
+                      <a:srgbClr val="FFFFFF"/>
+                    </a:solidFill>
+                  </a:tcPr>
+                </a:tc>
+              </a:tr>
+              <a:tr h="384048">
+                <a:tc>
+                  <a:txBody>
+                    <a:bodyPr/>
+                    <a:lstStyle/>
+                    <a:p>
+                      <a:pPr indent="0" marL="0">
+                        <a:buNone/>
+                      </a:pPr>
+                      <a:r>
+                        <a:rPr lang="en-US" sz="1050" dirty="0">
+                          <a:solidFill>
+                            <a:srgbClr val="0F172A"/>
+                          </a:solidFill>
+                          <a:latin typeface="Segoe UI" pitchFamily="34" charset="0"/>
+                          <a:ea typeface="Segoe UI" pitchFamily="34" charset="-122"/>
+                          <a:cs typeface="Segoe UI" pitchFamily="34" charset="-120"/>
+                        </a:rPr>
+                        <a:t>Khoản thu</a:t>
+                      </a:r>
+                      <a:endParaRPr lang="en-US" sz="1050" dirty="0">
+                        <a:latin typeface="Segoe UI" charset="0"/>
+                        <a:ea typeface="Segoe UI" charset="0"/>
+                        <a:cs typeface="Segoe UI" charset="0"/>
+                      </a:endParaRPr>
+                    </a:p>
+                  </a:txBody>
+                  <a:tcPr marL="73152" marR="73152" marT="73152" marB="73152" anchor="ctr">
+                    <a:lnL w="9525" cap="flat" cmpd="sng" algn="ctr">
+                      <a:solidFill>
+                        <a:srgbClr val="E2E8F0"/>
+                      </a:solidFill>
+                      <a:prstDash val="solid"/>
+                      <a:round/>
+                      <a:headEnd type="none" w="med" len="med"/>
+                      <a:tailEnd type="none" w="med" len="med"/>
+                    </a:lnL>
+                    <a:lnR w="9525" cap="flat" cmpd="sng" algn="ctr">
+                      <a:solidFill>
+                        <a:srgbClr val="E2E8F0"/>
+                      </a:solidFill>
+                      <a:prstDash val="solid"/>
+                      <a:round/>
+                      <a:headEnd type="none" w="med" len="med"/>
+                      <a:tailEnd type="none" w="med" len="med"/>
+                    </a:lnR>
+                    <a:lnT w="9525" cap="flat" cmpd="sng" algn="ctr">
+                      <a:solidFill>
+                        <a:srgbClr val="E2E8F0"/>
+                      </a:solidFill>
+                      <a:prstDash val="solid"/>
+                      <a:round/>
+                      <a:headEnd type="none" w="med" len="med"/>
+                      <a:tailEnd type="none" w="med" len="med"/>
+                    </a:lnT>
+                    <a:lnB w="9525" cap="flat" cmpd="sng" algn="ctr">
+                      <a:solidFill>
+                        <a:srgbClr val="E2E8F0"/>
+                      </a:solidFill>
+                      <a:prstDash val="solid"/>
+                      <a:round/>
+                      <a:headEnd type="none" w="med" len="med"/>
+                      <a:tailEnd type="none" w="med" len="med"/>
+                    </a:lnB>
+                    <a:solidFill>
+                      <a:srgbClr val="F8FAFC"/>
+                    </a:solidFill>
+                  </a:tcPr>
+                </a:tc>
+                <a:tc>
+                  <a:txBody>
+                    <a:bodyPr/>
+                    <a:lstStyle/>
+                    <a:p>
+                      <a:pPr indent="0" marL="0">
+                        <a:buNone/>
+                      </a:pPr>
+                      <a:r>
+                        <a:rPr lang="en-US" sz="1050" dirty="0">
+                          <a:solidFill>
+                            <a:srgbClr val="0F172A"/>
+                          </a:solidFill>
+                          <a:latin typeface="Segoe UI" pitchFamily="34" charset="0"/>
+                          <a:ea typeface="Segoe UI" pitchFamily="34" charset="-122"/>
+                          <a:cs typeface="Segoe UI" pitchFamily="34" charset="-120"/>
+                        </a:rPr>
+                        <a:t>finance/</a:t>
+                      </a:r>
+                      <a:endParaRPr lang="en-US" sz="1050" dirty="0">
+                        <a:latin typeface="Segoe UI" charset="0"/>
+                        <a:ea typeface="Segoe UI" charset="0"/>
+                        <a:cs typeface="Segoe UI" charset="0"/>
+                      </a:endParaRPr>
+                    </a:p>
+                  </a:txBody>
+                  <a:tcPr marL="73152" marR="73152" marT="73152" marB="73152" anchor="ctr">
+                    <a:lnL w="9525" cap="flat" cmpd="sng" algn="ctr">
+                      <a:solidFill>
+                        <a:srgbClr val="E2E8F0"/>
+                      </a:solidFill>
+                      <a:prstDash val="solid"/>
+                      <a:round/>
+                      <a:headEnd type="none" w="med" len="med"/>
+                      <a:tailEnd type="none" w="med" len="med"/>
+                    </a:lnL>
+                    <a:lnR w="9525" cap="flat" cmpd="sng" algn="ctr">
+                      <a:solidFill>
+                        <a:srgbClr val="E2E8F0"/>
+                      </a:solidFill>
+                      <a:prstDash val="solid"/>
+                      <a:round/>
+                      <a:headEnd type="none" w="med" len="med"/>
+                      <a:tailEnd type="none" w="med" len="med"/>
+                    </a:lnR>
+                    <a:lnT w="9525" cap="flat" cmpd="sng" algn="ctr">
+                      <a:solidFill>
+                        <a:srgbClr val="E2E8F0"/>
+                      </a:solidFill>
+                      <a:prstDash val="solid"/>
+                      <a:round/>
+                      <a:headEnd type="none" w="med" len="med"/>
+                      <a:tailEnd type="none" w="med" len="med"/>
+                    </a:lnT>
+                    <a:lnB w="9525" cap="flat" cmpd="sng" algn="ctr">
+                      <a:solidFill>
+                        <a:srgbClr val="E2E8F0"/>
+                      </a:solidFill>
+                      <a:prstDash val="solid"/>
+                      <a:round/>
+                      <a:headEnd type="none" w="med" len="med"/>
+                      <a:tailEnd type="none" w="med" len="med"/>
+                    </a:lnB>
+                    <a:solidFill>
+                      <a:srgbClr val="F8FAFC"/>
+                    </a:solidFill>
+                  </a:tcPr>
+                </a:tc>
+                <a:tc>
+                  <a:txBody>
+                    <a:bodyPr/>
+                    <a:lstStyle/>
+                    <a:p>
+                      <a:pPr indent="0" marL="0">
+                        <a:buNone/>
+                      </a:pPr>
+                      <a:r>
+                        <a:rPr lang="en-US" sz="1050" dirty="0">
+                          <a:solidFill>
+                            <a:srgbClr val="0F172A"/>
+                          </a:solidFill>
+                          <a:latin typeface="Segoe UI" pitchFamily="34" charset="0"/>
+                          <a:ea typeface="Segoe UI" pitchFamily="34" charset="-122"/>
+                          <a:cs typeface="Segoe UI" pitchFamily="34" charset="-120"/>
+                        </a:rPr>
+                        <a:t>fee_items, periods, receipts</a:t>
+                      </a:r>
+                      <a:endParaRPr lang="en-US" sz="1050" dirty="0">
+                        <a:latin typeface="Segoe UI" charset="0"/>
+                        <a:ea typeface="Segoe UI" charset="0"/>
+                        <a:cs typeface="Segoe UI" charset="0"/>
+                      </a:endParaRPr>
+                    </a:p>
+                  </a:txBody>
+                  <a:tcPr marL="73152" marR="73152" marT="73152" marB="73152" anchor="ctr">
+                    <a:lnL w="9525" cap="flat" cmpd="sng" algn="ctr">
+                      <a:solidFill>
+                        <a:srgbClr val="E2E8F0"/>
+                      </a:solidFill>
+                      <a:prstDash val="solid"/>
+                      <a:round/>
+                      <a:headEnd type="none" w="med" len="med"/>
+                      <a:tailEnd type="none" w="med" len="med"/>
+                    </a:lnL>
+                    <a:lnR w="9525" cap="flat" cmpd="sng" algn="ctr">
+                      <a:solidFill>
+                        <a:srgbClr val="E2E8F0"/>
+                      </a:solidFill>
+                      <a:prstDash val="solid"/>
+                      <a:round/>
+                      <a:headEnd type="none" w="med" len="med"/>
+                      <a:tailEnd type="none" w="med" len="med"/>
+                    </a:lnR>
+                    <a:lnT w="9525" cap="flat" cmpd="sng" algn="ctr">
+                      <a:solidFill>
+                        <a:srgbClr val="E2E8F0"/>
+                      </a:solidFill>
+                      <a:prstDash val="solid"/>
+                      <a:round/>
+                      <a:headEnd type="none" w="med" len="med"/>
+                      <a:tailEnd type="none" w="med" len="med"/>
+                    </a:lnT>
+                    <a:lnB w="9525" cap="flat" cmpd="sng" algn="ctr">
+                      <a:solidFill>
+                        <a:srgbClr val="E2E8F0"/>
+                      </a:solidFill>
+                      <a:prstDash val="solid"/>
+                      <a:round/>
+                      <a:headEnd type="none" w="med" len="med"/>
+                      <a:tailEnd type="none" w="med" len="med"/>
+                    </a:lnB>
+                    <a:solidFill>
+                      <a:srgbClr val="F8FAFC"/>
+                    </a:solidFill>
+                  </a:tcPr>
+                </a:tc>
+              </a:tr>
+              <a:tr h="384048">
+                <a:tc>
+                  <a:txBody>
+                    <a:bodyPr/>
+                    <a:lstStyle/>
+                    <a:p>
+                      <a:pPr indent="0" marL="0">
+                        <a:buNone/>
+                      </a:pPr>
+                      <a:r>
+                        <a:rPr lang="en-US" sz="1050" dirty="0">
+                          <a:solidFill>
+                            <a:srgbClr val="0F172A"/>
+                          </a:solidFill>
+                          <a:latin typeface="Segoe UI" pitchFamily="34" charset="0"/>
+                          <a:ea typeface="Segoe UI" pitchFamily="34" charset="-122"/>
+                          <a:cs typeface="Segoe UI" pitchFamily="34" charset="-120"/>
+                        </a:rPr>
+                        <a:t>LMS-lite</a:t>
+                      </a:r>
+                      <a:endParaRPr lang="en-US" sz="1050" dirty="0">
+                        <a:latin typeface="Segoe UI" charset="0"/>
+                        <a:ea typeface="Segoe UI" charset="0"/>
+                        <a:cs typeface="Segoe UI" charset="0"/>
+                      </a:endParaRPr>
+                    </a:p>
+                  </a:txBody>
+                  <a:tcPr marL="73152" marR="73152" marT="73152" marB="73152" anchor="ctr">
+                    <a:lnL w="9525" cap="flat" cmpd="sng" algn="ctr">
+                      <a:solidFill>
+                        <a:srgbClr val="E2E8F0"/>
+                      </a:solidFill>
+                      <a:prstDash val="solid"/>
+                      <a:round/>
+                      <a:headEnd type="none" w="med" len="med"/>
+                      <a:tailEnd type="none" w="med" len="med"/>
+                    </a:lnL>
+                    <a:lnR w="9525" cap="flat" cmpd="sng" algn="ctr">
+                      <a:solidFill>
+                        <a:srgbClr val="E2E8F0"/>
+                      </a:solidFill>
+                      <a:prstDash val="solid"/>
+                      <a:round/>
+                      <a:headEnd type="none" w="med" len="med"/>
+                      <a:tailEnd type="none" w="med" len="med"/>
+                    </a:lnR>
+                    <a:lnT w="9525" cap="flat" cmpd="sng" algn="ctr">
+                      <a:solidFill>
+                        <a:srgbClr val="E2E8F0"/>
+                      </a:solidFill>
+                      <a:prstDash val="solid"/>
+                      <a:round/>
+                      <a:headEnd type="none" w="med" len="med"/>
+                      <a:tailEnd type="none" w="med" len="med"/>
+                    </a:lnT>
+                    <a:lnB w="9525" cap="flat" cmpd="sng" algn="ctr">
+                      <a:solidFill>
+                        <a:srgbClr val="E2E8F0"/>
+                      </a:solidFill>
+                      <a:prstDash val="solid"/>
+                      <a:round/>
+                      <a:headEnd type="none" w="med" len="med"/>
+                      <a:tailEnd type="none" w="med" len="med"/>
+                    </a:lnB>
+                    <a:solidFill>
+                      <a:srgbClr val="FFFFFF"/>
+                    </a:solidFill>
+                  </a:tcPr>
+                </a:tc>
+                <a:tc>
+                  <a:txBody>
+                    <a:bodyPr/>
+                    <a:lstStyle/>
+                    <a:p>
+                      <a:pPr indent="0" marL="0">
+                        <a:buNone/>
+                      </a:pPr>
+                      <a:r>
+                        <a:rPr lang="en-US" sz="1050" dirty="0">
+                          <a:solidFill>
+                            <a:srgbClr val="0F172A"/>
+                          </a:solidFill>
+                          <a:latin typeface="Segoe UI" pitchFamily="34" charset="0"/>
+                          <a:ea typeface="Segoe UI" pitchFamily="34" charset="-122"/>
+                          <a:cs typeface="Segoe UI" pitchFamily="34" charset="-120"/>
+                        </a:rPr>
+                        <a:t>lms/ + portal/student/bai-thi</a:t>
+                      </a:r>
+                      <a:endParaRPr lang="en-US" sz="1050" dirty="0">
+                        <a:latin typeface="Segoe UI" charset="0"/>
+                        <a:ea typeface="Segoe UI" charset="0"/>
+                        <a:cs typeface="Segoe UI" charset="0"/>
+                      </a:endParaRPr>
+                    </a:p>
+                  </a:txBody>
+                  <a:tcPr marL="73152" marR="73152" marT="73152" marB="73152" anchor="ctr">
+                    <a:lnL w="9525" cap="flat" cmpd="sng" algn="ctr">
+                      <a:solidFill>
+                        <a:srgbClr val="E2E8F0"/>
+                      </a:solidFill>
+                      <a:prstDash val="solid"/>
+                      <a:round/>
+                      <a:headEnd type="none" w="med" len="med"/>
+                      <a:tailEnd type="none" w="med" len="med"/>
+                    </a:lnL>
+                    <a:lnR w="9525" cap="flat" cmpd="sng" algn="ctr">
+                      <a:solidFill>
+                        <a:srgbClr val="E2E8F0"/>
+                      </a:solidFill>
+                      <a:prstDash val="solid"/>
+                      <a:round/>
+                      <a:headEnd type="none" w="med" len="med"/>
+                      <a:tailEnd type="none" w="med" len="med"/>
+                    </a:lnR>
+                    <a:lnT w="9525" cap="flat" cmpd="sng" algn="ctr">
+                      <a:solidFill>
+                        <a:srgbClr val="E2E8F0"/>
+                      </a:solidFill>
+                      <a:prstDash val="solid"/>
+                      <a:round/>
+                      <a:headEnd type="none" w="med" len="med"/>
+                      <a:tailEnd type="none" w="med" len="med"/>
+                    </a:lnT>
+                    <a:lnB w="9525" cap="flat" cmpd="sng" algn="ctr">
+                      <a:solidFill>
+                        <a:srgbClr val="E2E8F0"/>
+                      </a:solidFill>
+                      <a:prstDash val="solid"/>
+                      <a:round/>
+                      <a:headEnd type="none" w="med" len="med"/>
+                      <a:tailEnd type="none" w="med" len="med"/>
+                    </a:lnB>
+                    <a:solidFill>
+                      <a:srgbClr val="FFFFFF"/>
+                    </a:solidFill>
+                  </a:tcPr>
+                </a:tc>
+                <a:tc>
+                  <a:txBody>
+                    <a:bodyPr/>
+                    <a:lstStyle/>
+                    <a:p>
+                      <a:pPr indent="0" marL="0">
+                        <a:buNone/>
+                      </a:pPr>
+                      <a:r>
+                        <a:rPr lang="en-US" sz="1050" dirty="0">
+                          <a:solidFill>
+                            <a:srgbClr val="0F172A"/>
+                          </a:solidFill>
+                          <a:latin typeface="Segoe UI" pitchFamily="34" charset="0"/>
+                          <a:ea typeface="Segoe UI" pitchFamily="34" charset="-122"/>
+                          <a:cs typeface="Segoe UI" pitchFamily="34" charset="-120"/>
+                        </a:rPr>
+                        <a:t>exam_sessions, submissions</a:t>
+                      </a:r>
+                      <a:endParaRPr lang="en-US" sz="1050" dirty="0">
+                        <a:latin typeface="Segoe UI" charset="0"/>
+                        <a:ea typeface="Segoe UI" charset="0"/>
+                        <a:cs typeface="Segoe UI" charset="0"/>
+                      </a:endParaRPr>
+                    </a:p>
+                  </a:txBody>
+                  <a:tcPr marL="73152" marR="73152" marT="73152" marB="73152" anchor="ctr">
+                    <a:lnL w="9525" cap="flat" cmpd="sng" algn="ctr">
+                      <a:solidFill>
+                        <a:srgbClr val="E2E8F0"/>
+                      </a:solidFill>
+                      <a:prstDash val="solid"/>
+                      <a:round/>
+                      <a:headEnd type="none" w="med" len="med"/>
+                      <a:tailEnd type="none" w="med" len="med"/>
+                    </a:lnL>
+                    <a:lnR w="9525" cap="flat" cmpd="sng" algn="ctr">
+                      <a:solidFill>
+                        <a:srgbClr val="E2E8F0"/>
+                      </a:solidFill>
+                      <a:prstDash val="solid"/>
+                      <a:round/>
+                      <a:headEnd type="none" w="med" len="med"/>
+                      <a:tailEnd type="none" w="med" len="med"/>
+                    </a:lnR>
+                    <a:lnT w="9525" cap="flat" cmpd="sng" algn="ctr">
+                      <a:solidFill>
+                        <a:srgbClr val="E2E8F0"/>
+                      </a:solidFill>
+                      <a:prstDash val="solid"/>
+                      <a:round/>
+                      <a:headEnd type="none" w="med" len="med"/>
+                      <a:tailEnd type="none" w="med" len="med"/>
+                    </a:lnT>
+                    <a:lnB w="9525" cap="flat" cmpd="sng" algn="ctr">
+                      <a:solidFill>
+                        <a:srgbClr val="E2E8F0"/>
+                      </a:solidFill>
+                      <a:prstDash val="solid"/>
+                      <a:round/>
+                      <a:headEnd type="none" w="med" len="med"/>
+                      <a:tailEnd type="none" w="med" len="med"/>
+                    </a:lnB>
+                    <a:solidFill>
+                      <a:srgbClr val="FFFFFF"/>
+                    </a:solidFill>
+                  </a:tcPr>
+                </a:tc>
+              </a:tr>
+              <a:tr h="384048">
+                <a:tc>
+                  <a:txBody>
+                    <a:bodyPr/>
+                    <a:lstStyle/>
+                    <a:p>
+                      <a:pPr indent="0" marL="0">
+                        <a:buNone/>
+                      </a:pPr>
+                      <a:r>
+                        <a:rPr lang="en-US" sz="1050" dirty="0">
+                          <a:solidFill>
+                            <a:srgbClr val="0F172A"/>
+                          </a:solidFill>
+                          <a:latin typeface="Segoe UI" pitchFamily="34" charset="0"/>
+                          <a:ea typeface="Segoe UI" pitchFamily="34" charset="-122"/>
+                          <a:cs typeface="Segoe UI" pitchFamily="34" charset="-120"/>
+                        </a:rPr>
+                        <a:t>Thư viện</a:t>
+                      </a:r>
+                      <a:endParaRPr lang="en-US" sz="1050" dirty="0">
+                        <a:latin typeface="Segoe UI" charset="0"/>
+                        <a:ea typeface="Segoe UI" charset="0"/>
+                        <a:cs typeface="Segoe UI" charset="0"/>
+                      </a:endParaRPr>
+                    </a:p>
+                  </a:txBody>
+                  <a:tcPr marL="73152" marR="73152" marT="73152" marB="73152" anchor="ctr">
+                    <a:lnL w="9525" cap="flat" cmpd="sng" algn="ctr">
+                      <a:solidFill>
+                        <a:srgbClr val="E2E8F0"/>
+                      </a:solidFill>
+                      <a:prstDash val="solid"/>
+                      <a:round/>
+                      <a:headEnd type="none" w="med" len="med"/>
+                      <a:tailEnd type="none" w="med" len="med"/>
+                    </a:lnL>
+                    <a:lnR w="9525" cap="flat" cmpd="sng" algn="ctr">
+                      <a:solidFill>
+                        <a:srgbClr val="E2E8F0"/>
+                      </a:solidFill>
+                      <a:prstDash val="solid"/>
+                      <a:round/>
+                      <a:headEnd type="none" w="med" len="med"/>
+                      <a:tailEnd type="none" w="med" len="med"/>
+                    </a:lnR>
+                    <a:lnT w="9525" cap="flat" cmpd="sng" algn="ctr">
+                      <a:solidFill>
+                        <a:srgbClr val="E2E8F0"/>
+                      </a:solidFill>
+                      <a:prstDash val="solid"/>
+                      <a:round/>
+                      <a:headEnd type="none" w="med" len="med"/>
+                      <a:tailEnd type="none" w="med" len="med"/>
+                    </a:lnT>
+                    <a:lnB w="9525" cap="flat" cmpd="sng" algn="ctr">
+                      <a:solidFill>
+                        <a:srgbClr val="E2E8F0"/>
+                      </a:solidFill>
+                      <a:prstDash val="solid"/>
+                      <a:round/>
+                      <a:headEnd type="none" w="med" len="med"/>
+                      <a:tailEnd type="none" w="med" len="med"/>
+                    </a:lnB>
+                    <a:solidFill>
+                      <a:srgbClr val="F8FAFC"/>
+                    </a:solidFill>
+                  </a:tcPr>
+                </a:tc>
+                <a:tc>
+                  <a:txBody>
+                    <a:bodyPr/>
+                    <a:lstStyle/>
+                    <a:p>
+                      <a:pPr indent="0" marL="0">
+                        <a:buNone/>
+                      </a:pPr>
+                      <a:r>
+                        <a:rPr lang="en-US" sz="1050" dirty="0">
+                          <a:solidFill>
+                            <a:srgbClr val="0F172A"/>
+                          </a:solidFill>
+                          <a:latin typeface="Segoe UI" pitchFamily="34" charset="0"/>
+                          <a:ea typeface="Segoe UI" pitchFamily="34" charset="-122"/>
+                          <a:cs typeface="Segoe UI" pitchFamily="34" charset="-120"/>
+                        </a:rPr>
+                        <a:t>library/</a:t>
+                      </a:r>
+                      <a:endParaRPr lang="en-US" sz="1050" dirty="0">
+                        <a:latin typeface="Segoe UI" charset="0"/>
+                        <a:ea typeface="Segoe UI" charset="0"/>
+                        <a:cs typeface="Segoe UI" charset="0"/>
+                      </a:endParaRPr>
+                    </a:p>
+                  </a:txBody>
+                  <a:tcPr marL="73152" marR="73152" marT="73152" marB="73152" anchor="ctr">
+                    <a:lnL w="9525" cap="flat" cmpd="sng" algn="ctr">
+                      <a:solidFill>
+                        <a:srgbClr val="E2E8F0"/>
+                      </a:solidFill>
+                      <a:prstDash val="solid"/>
+                      <a:round/>
+                      <a:headEnd type="none" w="med" len="med"/>
+                      <a:tailEnd type="none" w="med" len="med"/>
+                    </a:lnL>
+                    <a:lnR w="9525" cap="flat" cmpd="sng" algn="ctr">
+                      <a:solidFill>
+                        <a:srgbClr val="E2E8F0"/>
+                      </a:solidFill>
+                      <a:prstDash val="solid"/>
+                      <a:round/>
+                      <a:headEnd type="none" w="med" len="med"/>
+                      <a:tailEnd type="none" w="med" len="med"/>
+                    </a:lnR>
+                    <a:lnT w="9525" cap="flat" cmpd="sng" algn="ctr">
+                      <a:solidFill>
+                        <a:srgbClr val="E2E8F0"/>
+                      </a:solidFill>
+                      <a:prstDash val="solid"/>
+                      <a:round/>
+                      <a:headEnd type="none" w="med" len="med"/>
+                      <a:tailEnd type="none" w="med" len="med"/>
+                    </a:lnT>
+                    <a:lnB w="9525" cap="flat" cmpd="sng" algn="ctr">
+                      <a:solidFill>
+                        <a:srgbClr val="E2E8F0"/>
+                      </a:solidFill>
+                      <a:prstDash val="solid"/>
+                      <a:round/>
+                      <a:headEnd type="none" w="med" len="med"/>
+                      <a:tailEnd type="none" w="med" len="med"/>
+                    </a:lnB>
+                    <a:solidFill>
+                      <a:srgbClr val="F8FAFC"/>
+                    </a:solidFill>
+                  </a:tcPr>
+                </a:tc>
+                <a:tc>
+                  <a:txBody>
+                    <a:bodyPr/>
+                    <a:lstStyle/>
+                    <a:p>
+                      <a:pPr indent="0" marL="0">
+                        <a:buNone/>
+                      </a:pPr>
+                      <a:r>
+                        <a:rPr lang="en-US" sz="1050" dirty="0">
+                          <a:solidFill>
+                            <a:srgbClr val="0F172A"/>
+                          </a:solidFill>
+                          <a:latin typeface="Segoe UI" pitchFamily="34" charset="0"/>
+                          <a:ea typeface="Segoe UI" pitchFamily="34" charset="-122"/>
+                          <a:cs typeface="Segoe UI" pitchFamily="34" charset="-120"/>
+                        </a:rPr>
+                        <a:t>catalog, dang_ky_ca_biet, loans</a:t>
+                      </a:r>
+                      <a:endParaRPr lang="en-US" sz="1050" dirty="0">
+                        <a:latin typeface="Segoe UI" charset="0"/>
+                        <a:ea typeface="Segoe UI" charset="0"/>
+                        <a:cs typeface="Segoe UI" charset="0"/>
+                      </a:endParaRPr>
+                    </a:p>
+                  </a:txBody>
+                  <a:tcPr marL="73152" marR="73152" marT="73152" marB="73152" anchor="ctr">
+                    <a:lnL w="9525" cap="flat" cmpd="sng" algn="ctr">
+                      <a:solidFill>
+                        <a:srgbClr val="E2E8F0"/>
+                      </a:solidFill>
+                      <a:prstDash val="solid"/>
+                      <a:round/>
+                      <a:headEnd type="none" w="med" len="med"/>
+                      <a:tailEnd type="none" w="med" len="med"/>
+                    </a:lnL>
+                    <a:lnR w="9525" cap="flat" cmpd="sng" algn="ctr">
+                      <a:solidFill>
+                        <a:srgbClr val="E2E8F0"/>
+                      </a:solidFill>
+                      <a:prstDash val="solid"/>
+                      <a:round/>
+                      <a:headEnd type="none" w="med" len="med"/>
+                      <a:tailEnd type="none" w="med" len="med"/>
+                    </a:lnR>
+                    <a:lnT w="9525" cap="flat" cmpd="sng" algn="ctr">
+                      <a:solidFill>
+                        <a:srgbClr val="E2E8F0"/>
+                      </a:solidFill>
+                      <a:prstDash val="solid"/>
+                      <a:round/>
+                      <a:headEnd type="none" w="med" len="med"/>
+                      <a:tailEnd type="none" w="med" len="med"/>
+                    </a:lnT>
+                    <a:lnB w="9525" cap="flat" cmpd="sng" algn="ctr">
+                      <a:solidFill>
+                        <a:srgbClr val="E2E8F0"/>
+                      </a:solidFill>
+                      <a:prstDash val="solid"/>
+                      <a:round/>
+                      <a:headEnd type="none" w="med" len="med"/>
+                      <a:tailEnd type="none" w="med" len="med"/>
+                    </a:lnB>
+                    <a:solidFill>
+                      <a:srgbClr val="F8FAFC"/>
+                    </a:solidFill>
+                  </a:tcPr>
+                </a:tc>
+              </a:tr>
+              <a:tr h="384048">
+                <a:tc>
+                  <a:txBody>
+                    <a:bodyPr/>
+                    <a:lstStyle/>
+                    <a:p>
+                      <a:pPr indent="0" marL="0">
+                        <a:buNone/>
+                      </a:pPr>
+                      <a:r>
+                        <a:rPr lang="en-US" sz="1050" dirty="0">
+                          <a:solidFill>
+                            <a:srgbClr val="0F172A"/>
+                          </a:solidFill>
+                          <a:latin typeface="Segoe UI" pitchFamily="34" charset="0"/>
+                          <a:ea typeface="Segoe UI" pitchFamily="34" charset="-122"/>
+                          <a:cs typeface="Segoe UI" pitchFamily="34" charset="-120"/>
+                        </a:rPr>
+                        <a:t>Biến động HS</a:t>
+                      </a:r>
+                      <a:endParaRPr lang="en-US" sz="1050" dirty="0">
+                        <a:latin typeface="Segoe UI" charset="0"/>
+                        <a:ea typeface="Segoe UI" charset="0"/>
+                        <a:cs typeface="Segoe UI" charset="0"/>
+                      </a:endParaRPr>
+                    </a:p>
+                  </a:txBody>
+                  <a:tcPr marL="73152" marR="73152" marT="73152" marB="73152" anchor="ctr">
+                    <a:lnL w="9525" cap="flat" cmpd="sng" algn="ctr">
+                      <a:solidFill>
+                        <a:srgbClr val="E2E8F0"/>
+                      </a:solidFill>
+                      <a:prstDash val="solid"/>
+                      <a:round/>
+                      <a:headEnd type="none" w="med" len="med"/>
+                      <a:tailEnd type="none" w="med" len="med"/>
+                    </a:lnL>
+                    <a:lnR w="9525" cap="flat" cmpd="sng" algn="ctr">
+                      <a:solidFill>
+                        <a:srgbClr val="E2E8F0"/>
+                      </a:solidFill>
+                      <a:prstDash val="solid"/>
+                      <a:round/>
+                      <a:headEnd type="none" w="med" len="med"/>
+                      <a:tailEnd type="none" w="med" len="med"/>
+                    </a:lnR>
+                    <a:lnT w="9525" cap="flat" cmpd="sng" algn="ctr">
+                      <a:solidFill>
+                        <a:srgbClr val="E2E8F0"/>
+                      </a:solidFill>
+                      <a:prstDash val="solid"/>
+                      <a:round/>
+                      <a:headEnd type="none" w="med" len="med"/>
+                      <a:tailEnd type="none" w="med" len="med"/>
+                    </a:lnT>
+                    <a:lnB w="9525" cap="flat" cmpd="sng" algn="ctr">
+                      <a:solidFill>
+                        <a:srgbClr val="E2E8F0"/>
+                      </a:solidFill>
+                      <a:prstDash val="solid"/>
+                      <a:round/>
+                      <a:headEnd type="none" w="med" len="med"/>
+                      <a:tailEnd type="none" w="med" len="med"/>
+                    </a:lnB>
+                    <a:solidFill>
+                      <a:srgbClr val="FFFFFF"/>
+                    </a:solidFill>
+                  </a:tcPr>
+                </a:tc>
+                <a:tc>
+                  <a:txBody>
+                    <a:bodyPr/>
+                    <a:lstStyle/>
+                    <a:p>
+                      <a:pPr indent="0" marL="0">
+                        <a:buNone/>
+                      </a:pPr>
+                      <a:r>
+                        <a:rPr lang="en-US" sz="1050" dirty="0">
+                          <a:solidFill>
+                            <a:srgbClr val="0F172A"/>
+                          </a:solidFill>
+                          <a:latin typeface="Segoe UI" pitchFamily="34" charset="0"/>
+                          <a:ea typeface="Segoe UI" pitchFamily="34" charset="-122"/>
+                          <a:cs typeface="Segoe UI" pitchFamily="34" charset="-120"/>
+                        </a:rPr>
+                        <a:t>movements/</a:t>
+                      </a:r>
+                      <a:endParaRPr lang="en-US" sz="1050" dirty="0">
+                        <a:latin typeface="Segoe UI" charset="0"/>
+                        <a:ea typeface="Segoe UI" charset="0"/>
+                        <a:cs typeface="Segoe UI" charset="0"/>
+                      </a:endParaRPr>
+                    </a:p>
+                  </a:txBody>
+                  <a:tcPr marL="73152" marR="73152" marT="73152" marB="73152" anchor="ctr">
+                    <a:lnL w="9525" cap="flat" cmpd="sng" algn="ctr">
+                      <a:solidFill>
+                        <a:srgbClr val="E2E8F0"/>
+                      </a:solidFill>
+                      <a:prstDash val="solid"/>
+                      <a:round/>
+                      <a:headEnd type="none" w="med" len="med"/>
+                      <a:tailEnd type="none" w="med" len="med"/>
+                    </a:lnL>
+                    <a:lnR w="9525" cap="flat" cmpd="sng" algn="ctr">
+                      <a:solidFill>
+                        <a:srgbClr val="E2E8F0"/>
+                      </a:solidFill>
+                      <a:prstDash val="solid"/>
+                      <a:round/>
+                      <a:headEnd type="none" w="med" len="med"/>
+                      <a:tailEnd type="none" w="med" len="med"/>
+                    </a:lnR>
+                    <a:lnT w="9525" cap="flat" cmpd="sng" algn="ctr">
+                      <a:solidFill>
+                        <a:srgbClr val="E2E8F0"/>
+                      </a:solidFill>
+                      <a:prstDash val="solid"/>
+                      <a:round/>
+                      <a:headEnd type="none" w="med" len="med"/>
+                      <a:tailEnd type="none" w="med" len="med"/>
+                    </a:lnT>
+                    <a:lnB w="9525" cap="flat" cmpd="sng" algn="ctr">
+                      <a:solidFill>
+                        <a:srgbClr val="E2E8F0"/>
+                      </a:solidFill>
+                      <a:prstDash val="solid"/>
+                      <a:round/>
+                      <a:headEnd type="none" w="med" len="med"/>
+                      <a:tailEnd type="none" w="med" len="med"/>
+                    </a:lnB>
+                    <a:solidFill>
+                      <a:srgbClr val="FFFFFF"/>
+                    </a:solidFill>
+                  </a:tcPr>
+                </a:tc>
+                <a:tc>
+                  <a:txBody>
+                    <a:bodyPr/>
+                    <a:lstStyle/>
+                    <a:p>
+                      <a:pPr indent="0" marL="0">
+                        <a:buNone/>
+                      </a:pPr>
+                      <a:r>
+                        <a:rPr lang="en-US" sz="1050" dirty="0">
+                          <a:solidFill>
+                            <a:srgbClr val="0F172A"/>
+                          </a:solidFill>
+                          <a:latin typeface="Segoe UI" pitchFamily="34" charset="0"/>
+                          <a:ea typeface="Segoe UI" pitchFamily="34" charset="-122"/>
+                          <a:cs typeface="Segoe UI" pitchFamily="34" charset="-120"/>
+                        </a:rPr>
+                        <a:t>movement_requests (RPC-only writes)</a:t>
+                      </a:r>
+                      <a:endParaRPr lang="en-US" sz="1050" dirty="0">
+                        <a:latin typeface="Segoe UI" charset="0"/>
+                        <a:ea typeface="Segoe UI" charset="0"/>
+                        <a:cs typeface="Segoe UI" charset="0"/>
+                      </a:endParaRPr>
+                    </a:p>
+                  </a:txBody>
+                  <a:tcPr marL="73152" marR="73152" marT="73152" marB="73152" anchor="ctr">
+                    <a:lnL w="9525" cap="flat" cmpd="sng" algn="ctr">
+                      <a:solidFill>
+                        <a:srgbClr val="E2E8F0"/>
+                      </a:solidFill>
+                      <a:prstDash val="solid"/>
+                      <a:round/>
+                      <a:headEnd type="none" w="med" len="med"/>
+                      <a:tailEnd type="none" w="med" len="med"/>
+                    </a:lnL>
+                    <a:lnR w="9525" cap="flat" cmpd="sng" algn="ctr">
+                      <a:solidFill>
+                        <a:srgbClr val="E2E8F0"/>
+                      </a:solidFill>
+                      <a:prstDash val="solid"/>
+                      <a:round/>
+                      <a:headEnd type="none" w="med" len="med"/>
+                      <a:tailEnd type="none" w="med" len="med"/>
+                    </a:lnR>
+                    <a:lnT w="9525" cap="flat" cmpd="sng" algn="ctr">
+                      <a:solidFill>
+                        <a:srgbClr val="E2E8F0"/>
+                      </a:solidFill>
+                      <a:prstDash val="solid"/>
+                      <a:round/>
+                      <a:headEnd type="none" w="med" len="med"/>
+                      <a:tailEnd type="none" w="med" len="med"/>
+                    </a:lnT>
+                    <a:lnB w="9525" cap="flat" cmpd="sng" algn="ctr">
+                      <a:solidFill>
+                        <a:srgbClr val="E2E8F0"/>
+                      </a:solidFill>
+                      <a:prstDash val="solid"/>
+                      <a:round/>
+                      <a:headEnd type="none" w="med" len="med"/>
+                      <a:tailEnd type="none" w="med" len="med"/>
+                    </a:lnB>
+                    <a:solidFill>
+                      <a:srgbClr val="FFFFFF"/>
+                    </a:solidFill>
+                  </a:tcPr>
+                </a:tc>
+              </a:tr>
+              <a:tr h="384048">
                 <a:tc>
                   <a:txBody>
                     <a:bodyPr/>
@@ -24677,7 +26584,7 @@
                       <a:tailEnd type="none" w="med" len="med"/>
                     </a:lnB>
                     <a:solidFill>
-                      <a:srgbClr val="FFFFFF"/>
+                      <a:srgbClr val="F8FAFC"/>
                     </a:solidFill>
                   </a:tcPr>
                 </a:tc>
@@ -24745,7 +26652,7 @@
                       <a:tailEnd type="none" w="med" len="med"/>
                     </a:lnB>
                     <a:solidFill>
-                      <a:srgbClr val="FFFFFF"/>
+                      <a:srgbClr val="F8FAFC"/>
                     </a:solidFill>
                   </a:tcPr>
                 </a:tc>
@@ -24766,7 +26673,7 @@
                           <a:ea typeface="Segoe UI" pitchFamily="34" charset="-122"/>
                           <a:cs typeface="Segoe UI" pitchFamily="34" charset="-120"/>
                         </a:rPr>
-                        <a:t>views aggregate</a:t>
+                        <a:t>views aggregate, school_features</a:t>
                       </a:r>
                       <a:endParaRPr lang="en-US" sz="1050" dirty="0">
                         <a:latin typeface="Segoe UI" charset="0"/>
@@ -24813,12 +26720,12 @@
                       <a:tailEnd type="none" w="med" len="med"/>
                     </a:lnB>
                     <a:solidFill>
-                      <a:srgbClr val="FFFFFF"/>
+                      <a:srgbClr val="F8FAFC"/>
                     </a:solidFill>
                   </a:tcPr>
                 </a:tc>
               </a:tr>
-              <a:tr h="420624">
+              <a:tr h="384048">
                 <a:tc>
                   <a:txBody>
                     <a:bodyPr/>
@@ -24883,7 +26790,7 @@
                       <a:tailEnd type="none" w="med" len="med"/>
                     </a:lnB>
                     <a:solidFill>
-                      <a:srgbClr val="F8FAFC"/>
+                      <a:srgbClr val="FFFFFF"/>
                     </a:solidFill>
                   </a:tcPr>
                 </a:tc>
@@ -24951,7 +26858,7 @@
                       <a:tailEnd type="none" w="med" len="med"/>
                     </a:lnB>
                     <a:solidFill>
-                      <a:srgbClr val="F8FAFC"/>
+                      <a:srgbClr val="FFFFFF"/>
                     </a:solidFill>
                   </a:tcPr>
                 </a:tc>
@@ -25019,7 +26926,7 @@
                       <a:tailEnd type="none" w="med" len="med"/>
                     </a:lnB>
                     <a:solidFill>
-                      <a:srgbClr val="F8FAFC"/>
+                      <a:srgbClr val="FFFFFF"/>
                     </a:solidFill>
                   </a:tcPr>
                 </a:tc>
@@ -25061,7 +26968,7 @@
                 <a:ea typeface="Segoe UI" pitchFamily="34" charset="-122"/>
                 <a:cs typeface="Segoe UI" pitchFamily="34" charset="-120"/>
               </a:rPr>
-              <a:t>Module = route group + bảng riêng + policy riêng. Ranh giới module được enforce bởi RLS, không phải network boundary.</a:t>
+              <a:t>15 bounded contexts. Module = route group + bảng riêng + policy riêng + module flag - tắt flag là tắt cả 4 lớp (nav/route/RPC/RLS), không chỉ ẩn menu.</a:t>
             </a:r>
             <a:endParaRPr lang="en-US" sz="1050" dirty="0"/>
           </a:p>
@@ -26025,7 +27932,7 @@
                           <a:ea typeface="Segoe UI" pitchFamily="34" charset="-122"/>
                           <a:cs typeface="Segoe UI" pitchFamily="34" charset="-120"/>
                         </a:rPr>
-                        <a:t>Function call trong process - join trực tiếp ~30 bảng</a:t>
+                        <a:t>Function call trong process - join trực tiếp 86 bảng</a:t>
                       </a:r>
                       <a:endParaRPr lang="en-US" sz="1050" dirty="0">
                         <a:latin typeface="Segoe UI" charset="0"/>
@@ -27241,7 +29148,7 @@
                 <a:ea typeface="Segoe UI" pitchFamily="34" charset="-122"/>
                 <a:cs typeface="Segoe UI" pitchFamily="34" charset="-120"/>
               </a:rPr>
-              <a:t>Microservices ở quy mô này = distributed monolith tệ hơn monolith tốt. Điểm tách hợp lý duy nhất hiện có: AI jobs - đã tách thành async pattern (bảng ai_jobs + callback) mà không cần service riêng.</a:t>
+              <a:t>Microservices ở quy mô này = distributed monolith tệ hơn monolith tốt. Sau wave CR-060..067 (5 module mới) kết luận càng đúng: tuyển sinh -&gt; nhập học -&gt; khoản thu -&gt; học bạ là 1 chuỗi transaction - chống tách tuyệt đối. Điểm tách hợp lý duy nhất: AI jobs - đã tách thành async pattern (ai_jobs + callback).</a:t>
             </a:r>
             <a:endParaRPr lang="en-US" sz="1300" dirty="0"/>
           </a:p>

</xml_diff>